<commit_message>
docs: rebuild the Phase 3 presentation with the ODBC slide
</commit_message>
<xml_diff>
--- a/docs/Phase 3 - Integration and Delivery.pptx
+++ b/docs/Phase 3 - Integration and Delivery.pptx
@@ -22,6 +22,7 @@
     <p:sldId id="267" r:id="rId18"/>
     <p:sldId id="268" r:id="rId19"/>
     <p:sldId id="269" r:id="rId20"/>
+    <p:sldId id="270" r:id="rId21"/>
   </p:sldIdLst>
   <p:sldSz cx="12192000" cy="6858000"/>
   <p:notesSz cx="6858000" cy="12192000"/>
@@ -2034,7 +2035,7 @@
                 </a:solidFill>
                 <a:latin typeface="Arial"/>
               </a:rPr>
-              <a:t>Part 10 · Testing and validation</a:t>
+              <a:t>Part 9 · Database connectivity</a:t>
             </a:r>
           </a:p>
         </p:txBody>
@@ -2089,7 +2090,7 @@
                 </a:solidFill>
                 <a:latin typeface="Georgia"/>
               </a:rPr>
-              <a:t>Test Strategy and Results</a:t>
+              <a:t>ODBC Client</a:t>
             </a:r>
           </a:p>
         </p:txBody>
@@ -2149,484 +2150,287 @@
           </a:p>
         </p:txBody>
       </p:sp>
-      <p:graphicFrame>
-        <p:nvGraphicFramePr>
-          <p:cNvPr id="5" name="Table 4"/>
-          <p:cNvGraphicFramePr>
-            <a:graphicFrameLocks noGrp="1"/>
-          </p:cNvGraphicFramePr>
+      <p:sp>
+        <p:nvSpPr>
+          <p:cNvPr id="5" name="Rounded Rectangle 4"/>
+          <p:cNvSpPr/>
           <p:nvPr/>
-        </p:nvGraphicFramePr>
-        <p:xfrm>
-          <a:off x="609904" y="1280160"/>
-          <a:ext cx="5852160" cy="2286000"/>
-        </p:xfrm>
-        <a:graphic>
-          <a:graphicData uri="http://schemas.openxmlformats.org/drawingml/2006/table">
-            <a:tbl>
-              <a:tblPr firstRow="1" bandRow="1">
-                <a:tableStyleId>{5C22544A-7EE6-4342-B048-85BDC9FD1C3A}</a:tableStyleId>
-              </a:tblPr>
-              <a:tblGrid>
-                <a:gridCol w="2926080"/>
-                <a:gridCol w="975360"/>
-                <a:gridCol w="975360"/>
-                <a:gridCol w="975360"/>
-              </a:tblGrid>
-              <a:tr h="457200">
-                <a:tc>
-                  <a:txBody>
-                    <a:bodyPr/>
-                    <a:lstStyle/>
-                    <a:p>
-                      <a:r>
-                        <a:rPr sz="1300" b="1">
-                          <a:solidFill>
-                            <a:srgbClr val="000000"/>
-                          </a:solidFill>
-                          <a:latin typeface="Arial"/>
-                        </a:rPr>
-                        <a:t>Category</a:t>
-                      </a:r>
-                    </a:p>
-                  </a:txBody>
-                  <a:tcPr marT="36576" marB="36576">
-                    <a:solidFill>
-                      <a:srgbClr val="E2E2DC"/>
-                    </a:solidFill>
-                  </a:tcPr>
-                </a:tc>
-                <a:tc>
-                  <a:txBody>
-                    <a:bodyPr/>
-                    <a:lstStyle/>
-                    <a:p>
-                      <a:r>
-                        <a:rPr sz="1300" b="1">
-                          <a:solidFill>
-                            <a:srgbClr val="000000"/>
-                          </a:solidFill>
-                          <a:latin typeface="Arial"/>
-                        </a:rPr>
-                        <a:t>Total</a:t>
-                      </a:r>
-                    </a:p>
-                  </a:txBody>
-                  <a:tcPr marT="36576" marB="36576">
-                    <a:solidFill>
-                      <a:srgbClr val="E2E2DC"/>
-                    </a:solidFill>
-                  </a:tcPr>
-                </a:tc>
-                <a:tc>
-                  <a:txBody>
-                    <a:bodyPr/>
-                    <a:lstStyle/>
-                    <a:p>
-                      <a:r>
-                        <a:rPr sz="1300" b="1">
-                          <a:solidFill>
-                            <a:srgbClr val="000000"/>
-                          </a:solidFill>
-                          <a:latin typeface="Arial"/>
-                        </a:rPr>
-                        <a:t>Passed</a:t>
-                      </a:r>
-                    </a:p>
-                  </a:txBody>
-                  <a:tcPr marT="36576" marB="36576">
-                    <a:solidFill>
-                      <a:srgbClr val="E2E2DC"/>
-                    </a:solidFill>
-                  </a:tcPr>
-                </a:tc>
-                <a:tc>
-                  <a:txBody>
-                    <a:bodyPr/>
-                    <a:lstStyle/>
-                    <a:p>
-                      <a:r>
-                        <a:rPr sz="1300" b="1">
-                          <a:solidFill>
-                            <a:srgbClr val="000000"/>
-                          </a:solidFill>
-                          <a:latin typeface="Arial"/>
-                        </a:rPr>
-                        <a:t>Failed</a:t>
-                      </a:r>
-                    </a:p>
-                  </a:txBody>
-                  <a:tcPr marT="36576" marB="36576">
-                    <a:solidFill>
-                      <a:srgbClr val="E2E2DC"/>
-                    </a:solidFill>
-                  </a:tcPr>
-                </a:tc>
-              </a:tr>
-              <a:tr h="457200">
-                <a:tc>
-                  <a:txBody>
-                    <a:bodyPr/>
-                    <a:lstStyle/>
-                    <a:p>
-                      <a:r>
-                        <a:rPr sz="1300" b="0">
-                          <a:solidFill>
-                            <a:srgbClr val="1F2933"/>
-                          </a:solidFill>
-                          <a:latin typeface="Arial"/>
-                        </a:rPr>
-                        <a:t>Functional</a:t>
-                      </a:r>
-                    </a:p>
-                  </a:txBody>
-                  <a:tcPr marT="36576" marB="36576">
-                    <a:solidFill>
-                      <a:srgbClr val="FFFFFF"/>
-                    </a:solidFill>
-                  </a:tcPr>
-                </a:tc>
-                <a:tc>
-                  <a:txBody>
-                    <a:bodyPr/>
-                    <a:lstStyle/>
-                    <a:p>
-                      <a:r>
-                        <a:rPr sz="1300" b="0">
-                          <a:solidFill>
-                            <a:srgbClr val="1F2933"/>
-                          </a:solidFill>
-                          <a:latin typeface="Arial"/>
-                        </a:rPr>
-                        <a:t>9</a:t>
-                      </a:r>
-                    </a:p>
-                  </a:txBody>
-                  <a:tcPr marT="36576" marB="36576">
-                    <a:solidFill>
-                      <a:srgbClr val="FFFFFF"/>
-                    </a:solidFill>
-                  </a:tcPr>
-                </a:tc>
-                <a:tc>
-                  <a:txBody>
-                    <a:bodyPr/>
-                    <a:lstStyle/>
-                    <a:p>
-                      <a:r>
-                        <a:rPr sz="1300" b="0">
-                          <a:solidFill>
-                            <a:srgbClr val="1F2933"/>
-                          </a:solidFill>
-                          <a:latin typeface="Arial"/>
-                        </a:rPr>
-                        <a:t>9</a:t>
-                      </a:r>
-                    </a:p>
-                  </a:txBody>
-                  <a:tcPr marT="36576" marB="36576">
-                    <a:solidFill>
-                      <a:srgbClr val="FFFFFF"/>
-                    </a:solidFill>
-                  </a:tcPr>
-                </a:tc>
-                <a:tc>
-                  <a:txBody>
-                    <a:bodyPr/>
-                    <a:lstStyle/>
-                    <a:p>
-                      <a:r>
-                        <a:rPr sz="1300" b="0">
-                          <a:solidFill>
-                            <a:srgbClr val="1F2933"/>
-                          </a:solidFill>
-                          <a:latin typeface="Arial"/>
-                        </a:rPr>
-                        <a:t>0</a:t>
-                      </a:r>
-                    </a:p>
-                  </a:txBody>
-                  <a:tcPr marT="36576" marB="36576">
-                    <a:solidFill>
-                      <a:srgbClr val="FFFFFF"/>
-                    </a:solidFill>
-                  </a:tcPr>
-                </a:tc>
-              </a:tr>
-              <a:tr h="457200">
-                <a:tc>
-                  <a:txBody>
-                    <a:bodyPr/>
-                    <a:lstStyle/>
-                    <a:p>
-                      <a:r>
-                        <a:rPr sz="1300" b="0">
-                          <a:solidFill>
-                            <a:srgbClr val="1F2933"/>
-                          </a:solidFill>
-                          <a:latin typeface="Arial"/>
-                        </a:rPr>
-                        <a:t>Constraint violation (incl. triggers, functions)</a:t>
-                      </a:r>
-                    </a:p>
-                  </a:txBody>
-                  <a:tcPr marT="36576" marB="36576">
-                    <a:solidFill>
-                      <a:srgbClr val="FFFFFF"/>
-                    </a:solidFill>
-                  </a:tcPr>
-                </a:tc>
-                <a:tc>
-                  <a:txBody>
-                    <a:bodyPr/>
-                    <a:lstStyle/>
-                    <a:p>
-                      <a:r>
-                        <a:rPr sz="1300" b="0">
-                          <a:solidFill>
-                            <a:srgbClr val="1F2933"/>
-                          </a:solidFill>
-                          <a:latin typeface="Arial"/>
-                        </a:rPr>
-                        <a:t>10</a:t>
-                      </a:r>
-                    </a:p>
-                  </a:txBody>
-                  <a:tcPr marT="36576" marB="36576">
-                    <a:solidFill>
-                      <a:srgbClr val="FFFFFF"/>
-                    </a:solidFill>
-                  </a:tcPr>
-                </a:tc>
-                <a:tc>
-                  <a:txBody>
-                    <a:bodyPr/>
-                    <a:lstStyle/>
-                    <a:p>
-                      <a:r>
-                        <a:rPr sz="1300" b="0">
-                          <a:solidFill>
-                            <a:srgbClr val="1F2933"/>
-                          </a:solidFill>
-                          <a:latin typeface="Arial"/>
-                        </a:rPr>
-                        <a:t>10</a:t>
-                      </a:r>
-                    </a:p>
-                  </a:txBody>
-                  <a:tcPr marT="36576" marB="36576">
-                    <a:solidFill>
-                      <a:srgbClr val="FFFFFF"/>
-                    </a:solidFill>
-                  </a:tcPr>
-                </a:tc>
-                <a:tc>
-                  <a:txBody>
-                    <a:bodyPr/>
-                    <a:lstStyle/>
-                    <a:p>
-                      <a:r>
-                        <a:rPr sz="1300" b="0">
-                          <a:solidFill>
-                            <a:srgbClr val="1F2933"/>
-                          </a:solidFill>
-                          <a:latin typeface="Arial"/>
-                        </a:rPr>
-                        <a:t>0</a:t>
-                      </a:r>
-                    </a:p>
-                  </a:txBody>
-                  <a:tcPr marT="36576" marB="36576">
-                    <a:solidFill>
-                      <a:srgbClr val="FFFFFF"/>
-                    </a:solidFill>
-                  </a:tcPr>
-                </a:tc>
-              </a:tr>
-              <a:tr h="457200">
-                <a:tc>
-                  <a:txBody>
-                    <a:bodyPr/>
-                    <a:lstStyle/>
-                    <a:p>
-                      <a:r>
-                        <a:rPr sz="1300" b="0">
-                          <a:solidFill>
-                            <a:srgbClr val="1F2933"/>
-                          </a:solidFill>
-                          <a:latin typeface="Arial"/>
-                        </a:rPr>
-                        <a:t>Error handling</a:t>
-                      </a:r>
-                    </a:p>
-                  </a:txBody>
-                  <a:tcPr marT="36576" marB="36576">
-                    <a:solidFill>
-                      <a:srgbClr val="FFFFFF"/>
-                    </a:solidFill>
-                  </a:tcPr>
-                </a:tc>
-                <a:tc>
-                  <a:txBody>
-                    <a:bodyPr/>
-                    <a:lstStyle/>
-                    <a:p>
-                      <a:r>
-                        <a:rPr sz="1300" b="0">
-                          <a:solidFill>
-                            <a:srgbClr val="1F2933"/>
-                          </a:solidFill>
-                          <a:latin typeface="Arial"/>
-                        </a:rPr>
-                        <a:t>4</a:t>
-                      </a:r>
-                    </a:p>
-                  </a:txBody>
-                  <a:tcPr marT="36576" marB="36576">
-                    <a:solidFill>
-                      <a:srgbClr val="FFFFFF"/>
-                    </a:solidFill>
-                  </a:tcPr>
-                </a:tc>
-                <a:tc>
-                  <a:txBody>
-                    <a:bodyPr/>
-                    <a:lstStyle/>
-                    <a:p>
-                      <a:r>
-                        <a:rPr sz="1300" b="0">
-                          <a:solidFill>
-                            <a:srgbClr val="1F2933"/>
-                          </a:solidFill>
-                          <a:latin typeface="Arial"/>
-                        </a:rPr>
-                        <a:t>4</a:t>
-                      </a:r>
-                    </a:p>
-                  </a:txBody>
-                  <a:tcPr marT="36576" marB="36576">
-                    <a:solidFill>
-                      <a:srgbClr val="FFFFFF"/>
-                    </a:solidFill>
-                  </a:tcPr>
-                </a:tc>
-                <a:tc>
-                  <a:txBody>
-                    <a:bodyPr/>
-                    <a:lstStyle/>
-                    <a:p>
-                      <a:r>
-                        <a:rPr sz="1300" b="0">
-                          <a:solidFill>
-                            <a:srgbClr val="1F2933"/>
-                          </a:solidFill>
-                          <a:latin typeface="Arial"/>
-                        </a:rPr>
-                        <a:t>0</a:t>
-                      </a:r>
-                    </a:p>
-                  </a:txBody>
-                  <a:tcPr marT="36576" marB="36576">
-                    <a:solidFill>
-                      <a:srgbClr val="FFFFFF"/>
-                    </a:solidFill>
-                  </a:tcPr>
-                </a:tc>
-              </a:tr>
-              <a:tr h="457200">
-                <a:tc>
-                  <a:txBody>
-                    <a:bodyPr/>
-                    <a:lstStyle/>
-                    <a:p>
-                      <a:r>
-                        <a:rPr sz="1300" b="0">
-                          <a:solidFill>
-                            <a:srgbClr val="1F2933"/>
-                          </a:solidFill>
-                          <a:latin typeface="Arial"/>
-                        </a:rPr>
-                        <a:t>Total documented cases</a:t>
-                      </a:r>
-                    </a:p>
-                  </a:txBody>
-                  <a:tcPr marT="36576" marB="36576">
-                    <a:solidFill>
-                      <a:srgbClr val="FFFFFF"/>
-                    </a:solidFill>
-                  </a:tcPr>
-                </a:tc>
-                <a:tc>
-                  <a:txBody>
-                    <a:bodyPr/>
-                    <a:lstStyle/>
-                    <a:p>
-                      <a:r>
-                        <a:rPr sz="1300" b="0">
-                          <a:solidFill>
-                            <a:srgbClr val="1F2933"/>
-                          </a:solidFill>
-                          <a:latin typeface="Arial"/>
-                        </a:rPr>
-                        <a:t>23</a:t>
-                      </a:r>
-                    </a:p>
-                  </a:txBody>
-                  <a:tcPr marT="36576" marB="36576">
-                    <a:solidFill>
-                      <a:srgbClr val="FFFFFF"/>
-                    </a:solidFill>
-                  </a:tcPr>
-                </a:tc>
-                <a:tc>
-                  <a:txBody>
-                    <a:bodyPr/>
-                    <a:lstStyle/>
-                    <a:p>
-                      <a:r>
-                        <a:rPr sz="1300" b="0">
-                          <a:solidFill>
-                            <a:srgbClr val="1F2933"/>
-                          </a:solidFill>
-                          <a:latin typeface="Arial"/>
-                        </a:rPr>
-                        <a:t>23</a:t>
-                      </a:r>
-                    </a:p>
-                  </a:txBody>
-                  <a:tcPr marT="36576" marB="36576">
-                    <a:solidFill>
-                      <a:srgbClr val="FFFFFF"/>
-                    </a:solidFill>
-                  </a:tcPr>
-                </a:tc>
-                <a:tc>
-                  <a:txBody>
-                    <a:bodyPr/>
-                    <a:lstStyle/>
-                    <a:p>
-                      <a:r>
-                        <a:rPr sz="1300" b="0">
-                          <a:solidFill>
-                            <a:srgbClr val="1F2933"/>
-                          </a:solidFill>
-                          <a:latin typeface="Arial"/>
-                        </a:rPr>
-                        <a:t>0</a:t>
-                      </a:r>
-                    </a:p>
-                  </a:txBody>
-                  <a:tcPr marT="36576" marB="36576">
-                    <a:solidFill>
-                      <a:srgbClr val="FFFFFF"/>
-                    </a:solidFill>
-                  </a:tcPr>
-                </a:tc>
-              </a:tr>
-            </a:tbl>
-          </a:graphicData>
-        </a:graphic>
-      </p:graphicFrame>
+        </p:nvSpPr>
+        <p:spPr>
+          <a:xfrm>
+            <a:off x="609904" y="1280160"/>
+            <a:ext cx="6766560" cy="3931920"/>
+          </a:xfrm>
+          <a:prstGeom prst="roundRect">
+            <a:avLst/>
+          </a:prstGeom>
+          <a:solidFill>
+            <a:srgbClr val="0F1B33"/>
+          </a:solidFill>
+          <a:ln>
+            <a:noFill/>
+          </a:ln>
+          <a:effectLst/>
+        </p:spPr>
+        <p:style>
+          <a:lnRef idx="1">
+            <a:schemeClr val="accent1"/>
+          </a:lnRef>
+          <a:fillRef idx="3">
+            <a:schemeClr val="accent1"/>
+          </a:fillRef>
+          <a:effectRef idx="2">
+            <a:schemeClr val="accent1"/>
+          </a:effectRef>
+          <a:fontRef idx="minor">
+            <a:schemeClr val="lt1"/>
+          </a:fontRef>
+        </p:style>
+        <p:txBody>
+          <a:bodyPr rtlCol="0" anchor="t" wrap="square" lIns="164592" rIns="164592"/>
+          <a:lstStyle/>
+          <a:p>
+            <a:pPr algn="l">
+              <a:spcAft>
+                <a:spcPts val="0"/>
+              </a:spcAft>
+            </a:pPr>
+            <a:r>
+              <a:rPr sz="1200" b="0">
+                <a:solidFill>
+                  <a:srgbClr val="E6EAF2"/>
+                </a:solidFill>
+                <a:latin typeface="Consolas"/>
+              </a:rPr>
+              <a:t>$driver = Get-OdbcDriver -Platform '64-bit' |</a:t>
+            </a:r>
+          </a:p>
+          <a:p>
+            <a:pPr algn="l">
+              <a:spcAft>
+                <a:spcPts val="0"/>
+              </a:spcAft>
+            </a:pPr>
+            <a:r>
+              <a:rPr sz="1200" b="0">
+                <a:solidFill>
+                  <a:srgbClr val="E6EAF2"/>
+                </a:solidFill>
+                <a:latin typeface="Consolas"/>
+              </a:rPr>
+              <a:t>    Where-Object Name -like '*UNICODE*'</a:t>
+            </a:r>
+          </a:p>
+          <a:p>
+            <a:pPr algn="l">
+              <a:spcAft>
+                <a:spcPts val="0"/>
+              </a:spcAft>
+            </a:pPr>
+            <a:r>
+              <a:rPr sz="1200" b="0">
+                <a:solidFill>
+                  <a:srgbClr val="E6EAF2"/>
+                </a:solidFill>
+                <a:latin typeface="Consolas"/>
+              </a:rPr>
+              <a:t>$cs = "Driver={$($driver.Name)};Server=localhost;"</a:t>
+            </a:r>
+          </a:p>
+          <a:p>
+            <a:pPr algn="l">
+              <a:spcAft>
+                <a:spcPts val="0"/>
+              </a:spcAft>
+            </a:pPr>
+            <a:r>
+              <a:rPr sz="1200" b="0">
+                <a:solidFill>
+                  <a:srgbClr val="E6EAF2"/>
+                </a:solidFill>
+                <a:latin typeface="Consolas"/>
+              </a:rPr>
+              <a:t>    + "Port=5432;Database=quiz_companion;Uid=postgres;Pwd=..."</a:t>
+            </a:r>
+          </a:p>
+          <a:p>
+            <a:pPr algn="l">
+              <a:spcAft>
+                <a:spcPts val="0"/>
+              </a:spcAft>
+            </a:pPr>
+            <a:r>
+              <a:rPr sz="1200" b="0">
+                <a:solidFill>
+                  <a:srgbClr val="E6EAF2"/>
+                </a:solidFill>
+                <a:latin typeface="Consolas"/>
+              </a:rPr>
+              <a:t>$db = New-Object System.Data.Odbc.OdbcConnection($cs)</a:t>
+            </a:r>
+          </a:p>
+          <a:p>
+            <a:pPr algn="l">
+              <a:spcAft>
+                <a:spcPts val="0"/>
+              </a:spcAft>
+            </a:pPr>
+            <a:r>
+              <a:rPr sz="1200" b="0">
+                <a:solidFill>
+                  <a:srgbClr val="E6EAF2"/>
+                </a:solidFill>
+                <a:latin typeface="Consolas"/>
+              </a:rPr>
+              <a:t>$db.Open()</a:t>
+            </a:r>
+          </a:p>
+          <a:p>
+            <a:pPr algn="l">
+              <a:spcAft>
+                <a:spcPts val="0"/>
+              </a:spcAft>
+            </a:pPr>
+            <a:r>
+              <a:rPr sz="1200" b="0">
+                <a:solidFill>
+                  <a:srgbClr val="E6EAF2"/>
+                </a:solidFill>
+                <a:latin typeface="Consolas"/>
+              </a:rPr>
+              <a:t> </a:t>
+            </a:r>
+          </a:p>
+          <a:p>
+            <a:pPr algn="l">
+              <a:spcAft>
+                <a:spcPts val="0"/>
+              </a:spcAft>
+            </a:pPr>
+            <a:r>
+              <a:rPr sz="1200" b="0">
+                <a:solidFill>
+                  <a:srgbClr val="E6EAF2"/>
+                </a:solidFill>
+                <a:latin typeface="Consolas"/>
+              </a:rPr>
+              <a:t># parameterised INSERT</a:t>
+            </a:r>
+          </a:p>
+          <a:p>
+            <a:pPr algn="l">
+              <a:spcAft>
+                <a:spcPts val="0"/>
+              </a:spcAft>
+            </a:pPr>
+            <a:r>
+              <a:rPr sz="1200" b="0">
+                <a:solidFill>
+                  <a:srgbClr val="E6EAF2"/>
+                </a:solidFill>
+                <a:latin typeface="Consolas"/>
+              </a:rPr>
+              <a:t>INSERT INTO topic (name, description, parent_topic_id)</a:t>
+            </a:r>
+          </a:p>
+          <a:p>
+            <a:pPr algn="l">
+              <a:spcAft>
+                <a:spcPts val="0"/>
+              </a:spcAft>
+            </a:pPr>
+            <a:r>
+              <a:rPr sz="1200" b="0">
+                <a:solidFill>
+                  <a:srgbClr val="E6EAF2"/>
+                </a:solidFill>
+                <a:latin typeface="Consolas"/>
+              </a:rPr>
+              <a:t>VALUES (?, ?, ?) RETURNING topic_id</a:t>
+            </a:r>
+          </a:p>
+          <a:p>
+            <a:pPr algn="l">
+              <a:spcAft>
+                <a:spcPts val="0"/>
+              </a:spcAft>
+            </a:pPr>
+            <a:r>
+              <a:rPr sz="1200" b="0">
+                <a:solidFill>
+                  <a:srgbClr val="E6EAF2"/>
+                </a:solidFill>
+                <a:latin typeface="Consolas"/>
+              </a:rPr>
+              <a:t> </a:t>
+            </a:r>
+          </a:p>
+          <a:p>
+            <a:pPr algn="l">
+              <a:spcAft>
+                <a:spcPts val="0"/>
+              </a:spcAft>
+            </a:pPr>
+            <a:r>
+              <a:rPr sz="1200" b="0">
+                <a:solidFill>
+                  <a:srgbClr val="E6EAF2"/>
+                </a:solidFill>
+                <a:latin typeface="Consolas"/>
+              </a:rPr>
+              <a:t># grade and record in one transaction</a:t>
+            </a:r>
+          </a:p>
+          <a:p>
+            <a:pPr algn="l">
+              <a:spcAft>
+                <a:spcPts val="0"/>
+              </a:spcAft>
+            </a:pPr>
+            <a:r>
+              <a:rPr sz="1200" b="0">
+                <a:solidFill>
+                  <a:srgbClr val="E6EAF2"/>
+                </a:solidFill>
+                <a:latin typeface="Consolas"/>
+              </a:rPr>
+              <a:t>SELECT grade_quiz(?, CAST(? AS jsonb))</a:t>
+            </a:r>
+          </a:p>
+          <a:p>
+            <a:pPr algn="l">
+              <a:spcAft>
+                <a:spcPts val="0"/>
+              </a:spcAft>
+            </a:pPr>
+            <a:r>
+              <a:rPr sz="1200" b="0">
+                <a:solidFill>
+                  <a:srgbClr val="E6EAF2"/>
+                </a:solidFill>
+                <a:latin typeface="Consolas"/>
+              </a:rPr>
+              <a:t>SELECT record_attempt(?, ?, 'completed', CAST(? AS numeric))</a:t>
+            </a:r>
+          </a:p>
+          <a:p>
+            <a:pPr algn="l">
+              <a:spcAft>
+                <a:spcPts val="0"/>
+              </a:spcAft>
+            </a:pPr>
+            <a:r>
+              <a:rPr sz="1200" b="0">
+                <a:solidFill>
+                  <a:srgbClr val="E6EAF2"/>
+                </a:solidFill>
+                <a:latin typeface="Consolas"/>
+              </a:rPr>
+              <a:t>$tx.Commit()   # $tx.Rollback() on error</a:t>
+            </a:r>
+          </a:p>
+        </p:txBody>
+      </p:sp>
       <p:sp>
         <p:nvSpPr>
           <p:cNvPr id="6" name="Rectangle 5"/>
@@ -2635,8 +2439,8 @@
         </p:nvSpPr>
         <p:spPr>
           <a:xfrm>
-            <a:off x="609904" y="3749039"/>
-            <a:ext cx="5852160" cy="2377440"/>
+            <a:off x="7589520" y="1280160"/>
+            <a:ext cx="4023360" cy="3931920"/>
           </a:xfrm>
           <a:prstGeom prst="rect">
             <a:avLst/>
@@ -2673,13 +2477,13 @@
               </a:spcAft>
             </a:pPr>
             <a:r>
-              <a:rPr sz="1500" b="1">
+              <a:rPr sz="1600" b="1">
                 <a:solidFill>
                   <a:srgbClr val="14284B"/>
                 </a:solidFill>
                 <a:latin typeface="Arial"/>
               </a:rPr>
-              <a:t>Three levels</a:t>
+              <a:t>odbc/OdbcDemo.ps1</a:t>
             </a:r>
           </a:p>
           <a:p>
@@ -2695,7 +2499,7 @@
                 </a:solidFill>
                 <a:latin typeface="Arial"/>
               </a:rPr>
-              <a:t>SQL: business_logic_tests.sql, rolled back.</a:t>
+              <a:t>PostgreSQL ODBC driver (psqlODBC, Unicode, 64-bit) through System.Data.Odbc.</a:t>
             </a:r>
           </a:p>
           <a:p>
@@ -2711,7 +2515,7 @@
                 </a:solidFill>
                 <a:latin typeface="Arial"/>
               </a:rPr>
-              <a:t>API: 31 automated tests on a separate, rebuilt test database.</a:t>
+              <a:t>Same menu and -Demo run as the JDBC client.</a:t>
             </a:r>
           </a:p>
           <a:p>
@@ -2727,7 +2531,7 @@
                 </a:solidFill>
                 <a:latin typeface="Arial"/>
               </a:rPr>
-              <a:t>Front end and JDBC: each screen run with valid and invalid input.</a:t>
+              <a:t>The demo ends with a rejected delete: trigger error 23001 “Topic 3 still has learning items”.</a:t>
             </a:r>
           </a:p>
           <a:p>
@@ -2743,240 +2547,7 @@
                 </a:solidFill>
                 <a:latin typeface="Arial"/>
               </a:rPr>
-              <a:t>One case failed first (NOW() vs TIMESTAMPTZ) and passed after the fix.</a:t>
-            </a:r>
-          </a:p>
-        </p:txBody>
-      </p:sp>
-      <p:sp>
-        <p:nvSpPr>
-          <p:cNvPr id="7" name="Rounded Rectangle 6"/>
-          <p:cNvSpPr/>
-          <p:nvPr/>
-        </p:nvSpPr>
-        <p:spPr>
-          <a:xfrm>
-            <a:off x="6675120" y="1280160"/>
-            <a:ext cx="4937760" cy="4846320"/>
-          </a:xfrm>
-          <a:prstGeom prst="roundRect">
-            <a:avLst/>
-          </a:prstGeom>
-          <a:solidFill>
-            <a:srgbClr val="0F1B33"/>
-          </a:solidFill>
-          <a:ln>
-            <a:noFill/>
-          </a:ln>
-          <a:effectLst/>
-        </p:spPr>
-        <p:style>
-          <a:lnRef idx="1">
-            <a:schemeClr val="accent1"/>
-          </a:lnRef>
-          <a:fillRef idx="3">
-            <a:schemeClr val="accent1"/>
-          </a:fillRef>
-          <a:effectRef idx="2">
-            <a:schemeClr val="accent1"/>
-          </a:effectRef>
-          <a:fontRef idx="minor">
-            <a:schemeClr val="lt1"/>
-          </a:fontRef>
-        </p:style>
-        <p:txBody>
-          <a:bodyPr rtlCol="0" anchor="t" wrap="square" lIns="164592" rIns="164592"/>
-          <a:lstStyle/>
-          <a:p>
-            <a:pPr algn="l">
-              <a:spcAft>
-                <a:spcPts val="0"/>
-              </a:spcAft>
-            </a:pPr>
-            <a:r>
-              <a:rPr sz="1400" b="0">
-                <a:solidFill>
-                  <a:srgbClr val="E6EAF2"/>
-                </a:solidFill>
-                <a:latin typeface="Consolas"/>
-              </a:rPr>
-              <a:t>PASS connectivity and retrieval</a:t>
-            </a:r>
-          </a:p>
-          <a:p>
-            <a:pPr algn="l">
-              <a:spcAft>
-                <a:spcPts val="0"/>
-              </a:spcAft>
-            </a:pPr>
-            <a:r>
-              <a:rPr sz="1400" b="0">
-                <a:solidFill>
-                  <a:srgbClr val="E6EAF2"/>
-                </a:solidFill>
-                <a:latin typeface="Consolas"/>
-              </a:rPr>
-              <a:t>PASS topics CRUD</a:t>
-            </a:r>
-          </a:p>
-          <a:p>
-            <a:pPr algn="l">
-              <a:spcAft>
-                <a:spcPts val="0"/>
-              </a:spcAft>
-            </a:pPr>
-            <a:r>
-              <a:rPr sz="1400" b="0">
-                <a:solidFill>
-                  <a:srgbClr val="E6EAF2"/>
-                </a:solidFill>
-                <a:latin typeface="Consolas"/>
-              </a:rPr>
-              <a:t>PASS learning items CRUD</a:t>
-            </a:r>
-          </a:p>
-          <a:p>
-            <a:pPr algn="l">
-              <a:spcAft>
-                <a:spcPts val="0"/>
-              </a:spcAft>
-            </a:pPr>
-            <a:r>
-              <a:rPr sz="1400" b="0">
-                <a:solidFill>
-                  <a:srgbClr val="E6EAF2"/>
-                </a:solidFill>
-                <a:latin typeface="Consolas"/>
-              </a:rPr>
-              <a:t>PASS questions CRUD</a:t>
-            </a:r>
-          </a:p>
-          <a:p>
-            <a:pPr algn="l">
-              <a:spcAft>
-                <a:spcPts val="0"/>
-              </a:spcAft>
-            </a:pPr>
-            <a:r>
-              <a:rPr sz="1400" b="0">
-                <a:solidFill>
-                  <a:srgbClr val="E6EAF2"/>
-                </a:solidFill>
-                <a:latin typeface="Consolas"/>
-              </a:rPr>
-              <a:t>PASS business rules through the API</a:t>
-            </a:r>
-          </a:p>
-          <a:p>
-            <a:pPr algn="l">
-              <a:spcAft>
-                <a:spcPts val="0"/>
-              </a:spcAft>
-            </a:pPr>
-            <a:r>
-              <a:rPr sz="1400" b="0">
-                <a:solidFill>
-                  <a:srgbClr val="E6EAF2"/>
-                </a:solidFill>
-                <a:latin typeface="Consolas"/>
-              </a:rPr>
-              <a:t>PASS accounts and users</a:t>
-            </a:r>
-          </a:p>
-          <a:p>
-            <a:pPr algn="l">
-              <a:spcAft>
-                <a:spcPts val="0"/>
-              </a:spcAft>
-            </a:pPr>
-            <a:r>
-              <a:rPr sz="1400" b="0">
-                <a:solidFill>
-                  <a:srgbClr val="E6EAF2"/>
-                </a:solidFill>
-                <a:latin typeface="Consolas"/>
-              </a:rPr>
-              <a:t>PASS error handling</a:t>
-            </a:r>
-          </a:p>
-          <a:p>
-            <a:pPr algn="l">
-              <a:spcAft>
-                <a:spcPts val="0"/>
-              </a:spcAft>
-            </a:pPr>
-            <a:r>
-              <a:rPr sz="1400" b="0">
-                <a:solidFill>
-                  <a:srgbClr val="E6EAF2"/>
-                </a:solidFill>
-                <a:latin typeface="Consolas"/>
-              </a:rPr>
-              <a:t>PASS vector recommendations</a:t>
-            </a:r>
-          </a:p>
-          <a:p>
-            <a:pPr algn="l">
-              <a:spcAft>
-                <a:spcPts val="0"/>
-              </a:spcAft>
-            </a:pPr>
-            <a:r>
-              <a:rPr sz="1400" b="0">
-                <a:solidFill>
-                  <a:srgbClr val="E6EAF2"/>
-                </a:solidFill>
-                <a:latin typeface="Consolas"/>
-              </a:rPr>
-              <a:t> </a:t>
-            </a:r>
-          </a:p>
-          <a:p>
-            <a:pPr algn="l">
-              <a:spcAft>
-                <a:spcPts val="0"/>
-              </a:spcAft>
-            </a:pPr>
-            <a:r>
-              <a:rPr sz="1400" b="0">
-                <a:solidFill>
-                  <a:srgbClr val="E6EAF2"/>
-                </a:solidFill>
-                <a:latin typeface="Consolas"/>
-              </a:rPr>
-              <a:t>tests 31</a:t>
-            </a:r>
-          </a:p>
-          <a:p>
-            <a:pPr algn="l">
-              <a:spcAft>
-                <a:spcPts val="0"/>
-              </a:spcAft>
-            </a:pPr>
-            <a:r>
-              <a:rPr sz="1400" b="0">
-                <a:solidFill>
-                  <a:srgbClr val="E6EAF2"/>
-                </a:solidFill>
-                <a:latin typeface="Consolas"/>
-              </a:rPr>
-              <a:t>pass 31</a:t>
-            </a:r>
-          </a:p>
-          <a:p>
-            <a:pPr algn="l">
-              <a:spcAft>
-                <a:spcPts val="0"/>
-              </a:spcAft>
-            </a:pPr>
-            <a:r>
-              <a:rPr sz="1400" b="0">
-                <a:solidFill>
-                  <a:srgbClr val="E6EAF2"/>
-                </a:solidFill>
-                <a:latin typeface="Consolas"/>
-              </a:rPr>
-              <a:t>fail 0</a:t>
+              <a:t>The quiz attempt is rolled back, so the sample data stays unchanged.</a:t>
             </a:r>
           </a:p>
         </p:txBody>
@@ -3049,7 +2620,7 @@
                 </a:solidFill>
                 <a:latin typeface="Arial"/>
               </a:rPr>
-              <a:t>Results</a:t>
+              <a:t>Part 10 · Testing and validation</a:t>
             </a:r>
           </a:p>
         </p:txBody>
@@ -3104,7 +2675,7 @@
                 </a:solidFill>
                 <a:latin typeface="Georgia"/>
               </a:rPr>
-              <a:t>Scope Achieved Against Phase 1</a:t>
+              <a:t>Test Strategy and Results</a:t>
             </a:r>
           </a:p>
         </p:txBody>
@@ -3174,7 +2745,7 @@
         </p:nvGraphicFramePr>
         <p:xfrm>
           <a:off x="609904" y="1280160"/>
-          <a:ext cx="10972800" cy="4114800"/>
+          <a:ext cx="5852160" cy="2286000"/>
         </p:xfrm>
         <a:graphic>
           <a:graphicData uri="http://schemas.openxmlformats.org/drawingml/2006/table">
@@ -3183,9 +2754,10 @@
                 <a:tableStyleId>{5C22544A-7EE6-4342-B048-85BDC9FD1C3A}</a:tableStyleId>
               </a:tblPr>
               <a:tblGrid>
-                <a:gridCol w="3657600"/>
-                <a:gridCol w="1463040"/>
-                <a:gridCol w="5852160"/>
+                <a:gridCol w="2926080"/>
+                <a:gridCol w="975360"/>
+                <a:gridCol w="975360"/>
+                <a:gridCol w="975360"/>
               </a:tblGrid>
               <a:tr h="457200">
                 <a:tc>
@@ -3194,13 +2766,13 @@
                     <a:lstStyle/>
                     <a:p>
                       <a:r>
-                        <a:rPr sz="1200" b="1">
+                        <a:rPr sz="1300" b="1">
                           <a:solidFill>
                             <a:srgbClr val="000000"/>
                           </a:solidFill>
                           <a:latin typeface="Arial"/>
                         </a:rPr>
-                        <a:t>Module (Phase 1 scope)</a:t>
+                        <a:t>Category</a:t>
                       </a:r>
                     </a:p>
                   </a:txBody>
@@ -3216,13 +2788,13 @@
                     <a:lstStyle/>
                     <a:p>
                       <a:r>
-                        <a:rPr sz="1200" b="1">
+                        <a:rPr sz="1300" b="1">
                           <a:solidFill>
                             <a:srgbClr val="000000"/>
                           </a:solidFill>
                           <a:latin typeface="Arial"/>
                         </a:rPr>
-                        <a:t>Status</a:t>
+                        <a:t>Total</a:t>
                       </a:r>
                     </a:p>
                   </a:txBody>
@@ -3238,13 +2810,35 @@
                     <a:lstStyle/>
                     <a:p>
                       <a:r>
-                        <a:rPr sz="1200" b="1">
+                        <a:rPr sz="1300" b="1">
                           <a:solidFill>
                             <a:srgbClr val="000000"/>
                           </a:solidFill>
                           <a:latin typeface="Arial"/>
                         </a:rPr>
-                        <a:t>Remarks</a:t>
+                        <a:t>Passed</a:t>
+                      </a:r>
+                    </a:p>
+                  </a:txBody>
+                  <a:tcPr marT="36576" marB="36576">
+                    <a:solidFill>
+                      <a:srgbClr val="E2E2DC"/>
+                    </a:solidFill>
+                  </a:tcPr>
+                </a:tc>
+                <a:tc>
+                  <a:txBody>
+                    <a:bodyPr/>
+                    <a:lstStyle/>
+                    <a:p>
+                      <a:r>
+                        <a:rPr sz="1300" b="1">
+                          <a:solidFill>
+                            <a:srgbClr val="000000"/>
+                          </a:solidFill>
+                          <a:latin typeface="Arial"/>
+                        </a:rPr>
+                        <a:t>Failed</a:t>
                       </a:r>
                     </a:p>
                   </a:txBody>
@@ -3262,13 +2856,13 @@
                     <a:lstStyle/>
                     <a:p>
                       <a:r>
-                        <a:rPr sz="1200" b="0">
+                        <a:rPr sz="1300" b="0">
                           <a:solidFill>
                             <a:srgbClr val="1F2933"/>
                           </a:solidFill>
                           <a:latin typeface="Arial"/>
                         </a:rPr>
-                        <a:t>Topics, quizzes, projects, questions</a:t>
+                        <a:t>Functional</a:t>
                       </a:r>
                     </a:p>
                   </a:txBody>
@@ -3284,13 +2878,13 @@
                     <a:lstStyle/>
                     <a:p>
                       <a:r>
-                        <a:rPr sz="1200" b="0">
+                        <a:rPr sz="1300" b="0">
                           <a:solidFill>
                             <a:srgbClr val="1F2933"/>
                           </a:solidFill>
                           <a:latin typeface="Arial"/>
                         </a:rPr>
-                        <a:t>Completed</a:t>
+                        <a:t>9</a:t>
                       </a:r>
                     </a:p>
                   </a:txBody>
@@ -3306,13 +2900,35 @@
                     <a:lstStyle/>
                     <a:p>
                       <a:r>
-                        <a:rPr sz="1200" b="0">
+                        <a:rPr sz="1300" b="0">
                           <a:solidFill>
                             <a:srgbClr val="1F2933"/>
                           </a:solidFill>
                           <a:latin typeface="Arial"/>
                         </a:rPr>
-                        <a:t>Full CRUD from the front end</a:t>
+                        <a:t>9</a:t>
+                      </a:r>
+                    </a:p>
+                  </a:txBody>
+                  <a:tcPr marT="36576" marB="36576">
+                    <a:solidFill>
+                      <a:srgbClr val="FFFFFF"/>
+                    </a:solidFill>
+                  </a:tcPr>
+                </a:tc>
+                <a:tc>
+                  <a:txBody>
+                    <a:bodyPr/>
+                    <a:lstStyle/>
+                    <a:p>
+                      <a:r>
+                        <a:rPr sz="1300" b="0">
+                          <a:solidFill>
+                            <a:srgbClr val="1F2933"/>
+                          </a:solidFill>
+                          <a:latin typeface="Arial"/>
+                        </a:rPr>
+                        <a:t>0</a:t>
                       </a:r>
                     </a:p>
                   </a:txBody>
@@ -3330,13 +2946,13 @@
                     <a:lstStyle/>
                     <a:p>
                       <a:r>
-                        <a:rPr sz="1200" b="0">
+                        <a:rPr sz="1300" b="0">
                           <a:solidFill>
                             <a:srgbClr val="1F2933"/>
                           </a:solidFill>
                           <a:latin typeface="Arial"/>
                         </a:rPr>
-                        <a:t>Quiz taking and grading</a:t>
+                        <a:t>Constraint violation (incl. triggers, functions)</a:t>
                       </a:r>
                     </a:p>
                   </a:txBody>
@@ -3352,13 +2968,13 @@
                     <a:lstStyle/>
                     <a:p>
                       <a:r>
-                        <a:rPr sz="1200" b="0">
+                        <a:rPr sz="1300" b="0">
                           <a:solidFill>
                             <a:srgbClr val="1F2933"/>
                           </a:solidFill>
                           <a:latin typeface="Arial"/>
                         </a:rPr>
-                        <a:t>Completed</a:t>
+                        <a:t>10</a:t>
                       </a:r>
                     </a:p>
                   </a:txBody>
@@ -3374,13 +2990,35 @@
                     <a:lstStyle/>
                     <a:p>
                       <a:r>
-                        <a:rPr sz="1200" b="0">
+                        <a:rPr sz="1300" b="0">
                           <a:solidFill>
                             <a:srgbClr val="1F2933"/>
                           </a:solidFill>
                           <a:latin typeface="Arial"/>
                         </a:rPr>
-                        <a:t>grade_quiz() and record_attempt() in one transaction</a:t>
+                        <a:t>10</a:t>
+                      </a:r>
+                    </a:p>
+                  </a:txBody>
+                  <a:tcPr marT="36576" marB="36576">
+                    <a:solidFill>
+                      <a:srgbClr val="FFFFFF"/>
+                    </a:solidFill>
+                  </a:tcPr>
+                </a:tc>
+                <a:tc>
+                  <a:txBody>
+                    <a:bodyPr/>
+                    <a:lstStyle/>
+                    <a:p>
+                      <a:r>
+                        <a:rPr sz="1300" b="0">
+                          <a:solidFill>
+                            <a:srgbClr val="1F2933"/>
+                          </a:solidFill>
+                          <a:latin typeface="Arial"/>
+                        </a:rPr>
+                        <a:t>0</a:t>
                       </a:r>
                     </a:p>
                   </a:txBody>
@@ -3398,13 +3036,13 @@
                     <a:lstStyle/>
                     <a:p>
                       <a:r>
-                        <a:rPr sz="1200" b="0">
+                        <a:rPr sz="1300" b="0">
                           <a:solidFill>
                             <a:srgbClr val="1F2933"/>
                           </a:solidFill>
                           <a:latin typeface="Arial"/>
                         </a:rPr>
-                        <a:t>Attempt history and topic proficiency</a:t>
+                        <a:t>Error handling</a:t>
                       </a:r>
                     </a:p>
                   </a:txBody>
@@ -3420,13 +3058,13 @@
                     <a:lstStyle/>
                     <a:p>
                       <a:r>
-                        <a:rPr sz="1200" b="0">
+                        <a:rPr sz="1300" b="0">
                           <a:solidFill>
                             <a:srgbClr val="1F2933"/>
                           </a:solidFill>
                           <a:latin typeface="Arial"/>
                         </a:rPr>
-                        <a:t>Completed</a:t>
+                        <a:t>4</a:t>
                       </a:r>
                     </a:p>
                   </a:txBody>
@@ -3442,13 +3080,35 @@
                     <a:lstStyle/>
                     <a:p>
                       <a:r>
-                        <a:rPr sz="1200" b="0">
+                        <a:rPr sz="1300" b="0">
                           <a:solidFill>
                             <a:srgbClr val="1F2933"/>
                           </a:solidFill>
                           <a:latin typeface="Arial"/>
                         </a:rPr>
-                        <a:t>Maintained by trigger trg_update_proficiency</a:t>
+                        <a:t>4</a:t>
+                      </a:r>
+                    </a:p>
+                  </a:txBody>
+                  <a:tcPr marT="36576" marB="36576">
+                    <a:solidFill>
+                      <a:srgbClr val="FFFFFF"/>
+                    </a:solidFill>
+                  </a:tcPr>
+                </a:tc>
+                <a:tc>
+                  <a:txBody>
+                    <a:bodyPr/>
+                    <a:lstStyle/>
+                    <a:p>
+                      <a:r>
+                        <a:rPr sz="1300" b="0">
+                          <a:solidFill>
+                            <a:srgbClr val="1F2933"/>
+                          </a:solidFill>
+                          <a:latin typeface="Arial"/>
+                        </a:rPr>
+                        <a:t>0</a:t>
                       </a:r>
                     </a:p>
                   </a:txBody>
@@ -3466,13 +3126,13 @@
                     <a:lstStyle/>
                     <a:p>
                       <a:r>
-                        <a:rPr sz="1200" b="0">
+                        <a:rPr sz="1300" b="0">
                           <a:solidFill>
                             <a:srgbClr val="1F2933"/>
                           </a:solidFill>
                           <a:latin typeface="Arial"/>
                         </a:rPr>
-                        <a:t>Recommendations</a:t>
+                        <a:t>Total documented cases</a:t>
                       </a:r>
                     </a:p>
                   </a:txBody>
@@ -3488,13 +3148,13 @@
                     <a:lstStyle/>
                     <a:p>
                       <a:r>
-                        <a:rPr sz="1200" b="0">
+                        <a:rPr sz="1300" b="0">
                           <a:solidFill>
                             <a:srgbClr val="1F2933"/>
                           </a:solidFill>
                           <a:latin typeface="Arial"/>
                         </a:rPr>
-                        <a:t>Completed</a:t>
+                        <a:t>23</a:t>
                       </a:r>
                     </a:p>
                   </a:txBody>
@@ -3510,13 +3170,13 @@
                     <a:lstStyle/>
                     <a:p>
                       <a:r>
-                        <a:rPr sz="1200" b="0">
+                        <a:rPr sz="1300" b="0">
                           <a:solidFill>
                             <a:srgbClr val="1F2933"/>
                           </a:solidFill>
                           <a:latin typeface="Arial"/>
                         </a:rPr>
-                        <a:t>Weak-topic rule plus pgvector similarity (replaces Qdrant)</a:t>
+                        <a:t>23</a:t>
                       </a:r>
                     </a:p>
                   </a:txBody>
@@ -3526,269 +3186,19 @@
                     </a:solidFill>
                   </a:tcPr>
                 </a:tc>
-              </a:tr>
-              <a:tr h="457200">
-                <a:tc>
-                  <a:txBody>
-                    <a:bodyPr/>
-                    <a:lstStyle/>
-                    <a:p>
-                      <a:r>
-                        <a:rPr sz="1200" b="0">
+                <a:tc>
+                  <a:txBody>
+                    <a:bodyPr/>
+                    <a:lstStyle/>
+                    <a:p>
+                      <a:r>
+                        <a:rPr sz="1300" b="0">
                           <a:solidFill>
                             <a:srgbClr val="1F2933"/>
                           </a:solidFill>
                           <a:latin typeface="Arial"/>
                         </a:rPr>
-                        <a:t>Leaderboard</a:t>
-                      </a:r>
-                    </a:p>
-                  </a:txBody>
-                  <a:tcPr marT="36576" marB="36576">
-                    <a:solidFill>
-                      <a:srgbClr val="FFFFFF"/>
-                    </a:solidFill>
-                  </a:tcPr>
-                </a:tc>
-                <a:tc>
-                  <a:txBody>
-                    <a:bodyPr/>
-                    <a:lstStyle/>
-                    <a:p>
-                      <a:r>
-                        <a:rPr sz="1200" b="0">
-                          <a:solidFill>
-                            <a:srgbClr val="1F2933"/>
-                          </a:solidFill>
-                          <a:latin typeface="Arial"/>
-                        </a:rPr>
-                        <a:t>Completed</a:t>
-                      </a:r>
-                    </a:p>
-                  </a:txBody>
-                  <a:tcPr marT="36576" marB="36576">
-                    <a:solidFill>
-                      <a:srgbClr val="FFFFFF"/>
-                    </a:solidFill>
-                  </a:tcPr>
-                </a:tc>
-                <a:tc>
-                  <a:txBody>
-                    <a:bodyPr/>
-                    <a:lstStyle/>
-                    <a:p>
-                      <a:r>
-                        <a:rPr sz="1200" b="0">
-                          <a:solidFill>
-                            <a:srgbClr val="1F2933"/>
-                          </a:solidFill>
-                          <a:latin typeface="Arial"/>
-                        </a:rPr>
-                        <a:t>View v_leaderboard</a:t>
-                      </a:r>
-                    </a:p>
-                  </a:txBody>
-                  <a:tcPr marT="36576" marB="36576">
-                    <a:solidFill>
-                      <a:srgbClr val="FFFFFF"/>
-                    </a:solidFill>
-                  </a:tcPr>
-                </a:tc>
-              </a:tr>
-              <a:tr h="457200">
-                <a:tc>
-                  <a:txBody>
-                    <a:bodyPr/>
-                    <a:lstStyle/>
-                    <a:p>
-                      <a:r>
-                        <a:rPr sz="1200" b="0">
-                          <a:solidFill>
-                            <a:srgbClr val="1F2933"/>
-                          </a:solidFill>
-                          <a:latin typeface="Arial"/>
-                        </a:rPr>
-                        <a:t>Student accounts</a:t>
-                      </a:r>
-                    </a:p>
-                  </a:txBody>
-                  <a:tcPr marT="36576" marB="36576">
-                    <a:solidFill>
-                      <a:srgbClr val="FFFFFF"/>
-                    </a:solidFill>
-                  </a:tcPr>
-                </a:tc>
-                <a:tc>
-                  <a:txBody>
-                    <a:bodyPr/>
-                    <a:lstStyle/>
-                    <a:p>
-                      <a:r>
-                        <a:rPr sz="1200" b="0">
-                          <a:solidFill>
-                            <a:srgbClr val="1F2933"/>
-                          </a:solidFill>
-                          <a:latin typeface="Arial"/>
-                        </a:rPr>
-                        <a:t>Partly</a:t>
-                      </a:r>
-                    </a:p>
-                  </a:txBody>
-                  <a:tcPr marT="36576" marB="36576">
-                    <a:solidFill>
-                      <a:srgbClr val="FFFFFF"/>
-                    </a:solidFill>
-                  </a:tcPr>
-                </a:tc>
-                <a:tc>
-                  <a:txBody>
-                    <a:bodyPr/>
-                    <a:lstStyle/>
-                    <a:p>
-                      <a:r>
-                        <a:rPr sz="1200" b="0">
-                          <a:solidFill>
-                            <a:srgbClr val="1F2933"/>
-                          </a:solidFill>
-                          <a:latin typeface="Arial"/>
-                        </a:rPr>
-                        <a:t>Sign-up and sign-in with hashed passwords; no sessions or roles yet</a:t>
-                      </a:r>
-                    </a:p>
-                  </a:txBody>
-                  <a:tcPr marT="36576" marB="36576">
-                    <a:solidFill>
-                      <a:srgbClr val="FFFFFF"/>
-                    </a:solidFill>
-                  </a:tcPr>
-                </a:tc>
-              </a:tr>
-              <a:tr h="457200">
-                <a:tc>
-                  <a:txBody>
-                    <a:bodyPr/>
-                    <a:lstStyle/>
-                    <a:p>
-                      <a:r>
-                        <a:rPr sz="1200" b="0">
-                          <a:solidFill>
-                            <a:srgbClr val="1F2933"/>
-                          </a:solidFill>
-                          <a:latin typeface="Arial"/>
-                        </a:rPr>
-                        <a:t>Caching of frequent reads (Redis)</a:t>
-                      </a:r>
-                    </a:p>
-                  </a:txBody>
-                  <a:tcPr marT="36576" marB="36576">
-                    <a:solidFill>
-                      <a:srgbClr val="FFFFFF"/>
-                    </a:solidFill>
-                  </a:tcPr>
-                </a:tc>
-                <a:tc>
-                  <a:txBody>
-                    <a:bodyPr/>
-                    <a:lstStyle/>
-                    <a:p>
-                      <a:r>
-                        <a:rPr sz="1200" b="0">
-                          <a:solidFill>
-                            <a:srgbClr val="1F2933"/>
-                          </a:solidFill>
-                          <a:latin typeface="Arial"/>
-                        </a:rPr>
-                        <a:t>Not built</a:t>
-                      </a:r>
-                    </a:p>
-                  </a:txBody>
-                  <a:tcPr marT="36576" marB="36576">
-                    <a:solidFill>
-                      <a:srgbClr val="FFFFFF"/>
-                    </a:solidFill>
-                  </a:tcPr>
-                </a:tc>
-                <a:tc>
-                  <a:txBody>
-                    <a:bodyPr/>
-                    <a:lstStyle/>
-                    <a:p>
-                      <a:r>
-                        <a:rPr sz="1200" b="0">
-                          <a:solidFill>
-                            <a:srgbClr val="1F2933"/>
-                          </a:solidFill>
-                          <a:latin typeface="Arial"/>
-                        </a:rPr>
-                        <a:t>Indexes added instead; not needed at this data size</a:t>
-                      </a:r>
-                    </a:p>
-                  </a:txBody>
-                  <a:tcPr marT="36576" marB="36576">
-                    <a:solidFill>
-                      <a:srgbClr val="FFFFFF"/>
-                    </a:solidFill>
-                  </a:tcPr>
-                </a:tc>
-              </a:tr>
-              <a:tr h="457200">
-                <a:tc>
-                  <a:txBody>
-                    <a:bodyPr/>
-                    <a:lstStyle/>
-                    <a:p>
-                      <a:r>
-                        <a:rPr sz="1200" b="0">
-                          <a:solidFill>
-                            <a:srgbClr val="1F2933"/>
-                          </a:solidFill>
-                          <a:latin typeface="Arial"/>
-                        </a:rPr>
-                        <a:t>Database connectivity</a:t>
-                      </a:r>
-                    </a:p>
-                  </a:txBody>
-                  <a:tcPr marT="36576" marB="36576">
-                    <a:solidFill>
-                      <a:srgbClr val="FFFFFF"/>
-                    </a:solidFill>
-                  </a:tcPr>
-                </a:tc>
-                <a:tc>
-                  <a:txBody>
-                    <a:bodyPr/>
-                    <a:lstStyle/>
-                    <a:p>
-                      <a:r>
-                        <a:rPr sz="1200" b="0">
-                          <a:solidFill>
-                            <a:srgbClr val="1F2933"/>
-                          </a:solidFill>
-                          <a:latin typeface="Arial"/>
-                        </a:rPr>
-                        <a:t>Completed</a:t>
-                      </a:r>
-                    </a:p>
-                  </a:txBody>
-                  <a:tcPr marT="36576" marB="36576">
-                    <a:solidFill>
-                      <a:srgbClr val="FFFFFF"/>
-                    </a:solidFill>
-                  </a:tcPr>
-                </a:tc>
-                <a:tc>
-                  <a:txBody>
-                    <a:bodyPr/>
-                    <a:lstStyle/>
-                    <a:p>
-                      <a:r>
-                        <a:rPr sz="1200" b="0">
-                          <a:solidFill>
-                            <a:srgbClr val="1F2933"/>
-                          </a:solidFill>
-                          <a:latin typeface="Arial"/>
-                        </a:rPr>
-                        <a:t>node-postgres for the web app; pgJDBC console client</a:t>
+                        <a:t>0</a:t>
                       </a:r>
                     </a:p>
                   </a:txBody>
@@ -3803,6 +3213,360 @@
           </a:graphicData>
         </a:graphic>
       </p:graphicFrame>
+      <p:sp>
+        <p:nvSpPr>
+          <p:cNvPr id="6" name="Rectangle 5"/>
+          <p:cNvSpPr/>
+          <p:nvPr/>
+        </p:nvSpPr>
+        <p:spPr>
+          <a:xfrm>
+            <a:off x="609904" y="3749039"/>
+            <a:ext cx="5852160" cy="2377440"/>
+          </a:xfrm>
+          <a:prstGeom prst="rect">
+            <a:avLst/>
+          </a:prstGeom>
+          <a:solidFill>
+            <a:srgbClr val="F3F4F6"/>
+          </a:solidFill>
+          <a:ln>
+            <a:noFill/>
+          </a:ln>
+          <a:effectLst/>
+        </p:spPr>
+        <p:style>
+          <a:lnRef idx="1">
+            <a:schemeClr val="accent1"/>
+          </a:lnRef>
+          <a:fillRef idx="3">
+            <a:schemeClr val="accent1"/>
+          </a:fillRef>
+          <a:effectRef idx="2">
+            <a:schemeClr val="accent1"/>
+          </a:effectRef>
+          <a:fontRef idx="minor">
+            <a:schemeClr val="lt1"/>
+          </a:fontRef>
+        </p:style>
+        <p:txBody>
+          <a:bodyPr rtlCol="0" anchor="t" wrap="square" lIns="164592" rIns="164592"/>
+          <a:lstStyle/>
+          <a:p>
+            <a:pPr algn="l">
+              <a:spcAft>
+                <a:spcPts val="400"/>
+              </a:spcAft>
+            </a:pPr>
+            <a:r>
+              <a:rPr sz="1500" b="1">
+                <a:solidFill>
+                  <a:srgbClr val="14284B"/>
+                </a:solidFill>
+                <a:latin typeface="Arial"/>
+              </a:rPr>
+              <a:t>Three levels</a:t>
+            </a:r>
+          </a:p>
+          <a:p>
+            <a:pPr algn="l">
+              <a:spcAft>
+                <a:spcPts val="400"/>
+              </a:spcAft>
+            </a:pPr>
+            <a:r>
+              <a:rPr sz="1300" b="0">
+                <a:solidFill>
+                  <a:srgbClr val="1F2933"/>
+                </a:solidFill>
+                <a:latin typeface="Arial"/>
+              </a:rPr>
+              <a:t>SQL: business_logic_tests.sql, rolled back.</a:t>
+            </a:r>
+          </a:p>
+          <a:p>
+            <a:pPr algn="l">
+              <a:spcAft>
+                <a:spcPts val="400"/>
+              </a:spcAft>
+            </a:pPr>
+            <a:r>
+              <a:rPr sz="1300" b="0">
+                <a:solidFill>
+                  <a:srgbClr val="1F2933"/>
+                </a:solidFill>
+                <a:latin typeface="Arial"/>
+              </a:rPr>
+              <a:t>API: 31 automated tests on a separate, rebuilt test database.</a:t>
+            </a:r>
+          </a:p>
+          <a:p>
+            <a:pPr algn="l">
+              <a:spcAft>
+                <a:spcPts val="400"/>
+              </a:spcAft>
+            </a:pPr>
+            <a:r>
+              <a:rPr sz="1300" b="0">
+                <a:solidFill>
+                  <a:srgbClr val="1F2933"/>
+                </a:solidFill>
+                <a:latin typeface="Arial"/>
+              </a:rPr>
+              <a:t>Front end, JDBC and ODBC: each run with valid and invalid input.</a:t>
+            </a:r>
+          </a:p>
+          <a:p>
+            <a:pPr algn="l">
+              <a:spcAft>
+                <a:spcPts val="400"/>
+              </a:spcAft>
+            </a:pPr>
+            <a:r>
+              <a:rPr sz="1300" b="0">
+                <a:solidFill>
+                  <a:srgbClr val="1F2933"/>
+                </a:solidFill>
+                <a:latin typeface="Arial"/>
+              </a:rPr>
+              <a:t>One case failed first (NOW() vs TIMESTAMPTZ) and passed after the fix.</a:t>
+            </a:r>
+          </a:p>
+        </p:txBody>
+      </p:sp>
+      <p:sp>
+        <p:nvSpPr>
+          <p:cNvPr id="7" name="Rounded Rectangle 6"/>
+          <p:cNvSpPr/>
+          <p:nvPr/>
+        </p:nvSpPr>
+        <p:spPr>
+          <a:xfrm>
+            <a:off x="6675120" y="1280160"/>
+            <a:ext cx="4937760" cy="4846320"/>
+          </a:xfrm>
+          <a:prstGeom prst="roundRect">
+            <a:avLst/>
+          </a:prstGeom>
+          <a:solidFill>
+            <a:srgbClr val="0F1B33"/>
+          </a:solidFill>
+          <a:ln>
+            <a:noFill/>
+          </a:ln>
+          <a:effectLst/>
+        </p:spPr>
+        <p:style>
+          <a:lnRef idx="1">
+            <a:schemeClr val="accent1"/>
+          </a:lnRef>
+          <a:fillRef idx="3">
+            <a:schemeClr val="accent1"/>
+          </a:fillRef>
+          <a:effectRef idx="2">
+            <a:schemeClr val="accent1"/>
+          </a:effectRef>
+          <a:fontRef idx="minor">
+            <a:schemeClr val="lt1"/>
+          </a:fontRef>
+        </p:style>
+        <p:txBody>
+          <a:bodyPr rtlCol="0" anchor="t" wrap="square" lIns="164592" rIns="164592"/>
+          <a:lstStyle/>
+          <a:p>
+            <a:pPr algn="l">
+              <a:spcAft>
+                <a:spcPts val="0"/>
+              </a:spcAft>
+            </a:pPr>
+            <a:r>
+              <a:rPr sz="1400" b="0">
+                <a:solidFill>
+                  <a:srgbClr val="E6EAF2"/>
+                </a:solidFill>
+                <a:latin typeface="Consolas"/>
+              </a:rPr>
+              <a:t>PASS connectivity and retrieval</a:t>
+            </a:r>
+          </a:p>
+          <a:p>
+            <a:pPr algn="l">
+              <a:spcAft>
+                <a:spcPts val="0"/>
+              </a:spcAft>
+            </a:pPr>
+            <a:r>
+              <a:rPr sz="1400" b="0">
+                <a:solidFill>
+                  <a:srgbClr val="E6EAF2"/>
+                </a:solidFill>
+                <a:latin typeface="Consolas"/>
+              </a:rPr>
+              <a:t>PASS topics CRUD</a:t>
+            </a:r>
+          </a:p>
+          <a:p>
+            <a:pPr algn="l">
+              <a:spcAft>
+                <a:spcPts val="0"/>
+              </a:spcAft>
+            </a:pPr>
+            <a:r>
+              <a:rPr sz="1400" b="0">
+                <a:solidFill>
+                  <a:srgbClr val="E6EAF2"/>
+                </a:solidFill>
+                <a:latin typeface="Consolas"/>
+              </a:rPr>
+              <a:t>PASS learning items CRUD</a:t>
+            </a:r>
+          </a:p>
+          <a:p>
+            <a:pPr algn="l">
+              <a:spcAft>
+                <a:spcPts val="0"/>
+              </a:spcAft>
+            </a:pPr>
+            <a:r>
+              <a:rPr sz="1400" b="0">
+                <a:solidFill>
+                  <a:srgbClr val="E6EAF2"/>
+                </a:solidFill>
+                <a:latin typeface="Consolas"/>
+              </a:rPr>
+              <a:t>PASS questions CRUD</a:t>
+            </a:r>
+          </a:p>
+          <a:p>
+            <a:pPr algn="l">
+              <a:spcAft>
+                <a:spcPts val="0"/>
+              </a:spcAft>
+            </a:pPr>
+            <a:r>
+              <a:rPr sz="1400" b="0">
+                <a:solidFill>
+                  <a:srgbClr val="E6EAF2"/>
+                </a:solidFill>
+                <a:latin typeface="Consolas"/>
+              </a:rPr>
+              <a:t>PASS business rules through the API</a:t>
+            </a:r>
+          </a:p>
+          <a:p>
+            <a:pPr algn="l">
+              <a:spcAft>
+                <a:spcPts val="0"/>
+              </a:spcAft>
+            </a:pPr>
+            <a:r>
+              <a:rPr sz="1400" b="0">
+                <a:solidFill>
+                  <a:srgbClr val="E6EAF2"/>
+                </a:solidFill>
+                <a:latin typeface="Consolas"/>
+              </a:rPr>
+              <a:t>PASS accounts and users</a:t>
+            </a:r>
+          </a:p>
+          <a:p>
+            <a:pPr algn="l">
+              <a:spcAft>
+                <a:spcPts val="0"/>
+              </a:spcAft>
+            </a:pPr>
+            <a:r>
+              <a:rPr sz="1400" b="0">
+                <a:solidFill>
+                  <a:srgbClr val="E6EAF2"/>
+                </a:solidFill>
+                <a:latin typeface="Consolas"/>
+              </a:rPr>
+              <a:t>PASS error handling</a:t>
+            </a:r>
+          </a:p>
+          <a:p>
+            <a:pPr algn="l">
+              <a:spcAft>
+                <a:spcPts val="0"/>
+              </a:spcAft>
+            </a:pPr>
+            <a:r>
+              <a:rPr sz="1400" b="0">
+                <a:solidFill>
+                  <a:srgbClr val="E6EAF2"/>
+                </a:solidFill>
+                <a:latin typeface="Consolas"/>
+              </a:rPr>
+              <a:t>PASS vector recommendations</a:t>
+            </a:r>
+          </a:p>
+          <a:p>
+            <a:pPr algn="l">
+              <a:spcAft>
+                <a:spcPts val="0"/>
+              </a:spcAft>
+            </a:pPr>
+            <a:r>
+              <a:rPr sz="1400" b="0">
+                <a:solidFill>
+                  <a:srgbClr val="E6EAF2"/>
+                </a:solidFill>
+                <a:latin typeface="Consolas"/>
+              </a:rPr>
+              <a:t> </a:t>
+            </a:r>
+          </a:p>
+          <a:p>
+            <a:pPr algn="l">
+              <a:spcAft>
+                <a:spcPts val="0"/>
+              </a:spcAft>
+            </a:pPr>
+            <a:r>
+              <a:rPr sz="1400" b="0">
+                <a:solidFill>
+                  <a:srgbClr val="E6EAF2"/>
+                </a:solidFill>
+                <a:latin typeface="Consolas"/>
+              </a:rPr>
+              <a:t>tests 31</a:t>
+            </a:r>
+          </a:p>
+          <a:p>
+            <a:pPr algn="l">
+              <a:spcAft>
+                <a:spcPts val="0"/>
+              </a:spcAft>
+            </a:pPr>
+            <a:r>
+              <a:rPr sz="1400" b="0">
+                <a:solidFill>
+                  <a:srgbClr val="E6EAF2"/>
+                </a:solidFill>
+                <a:latin typeface="Consolas"/>
+              </a:rPr>
+              <a:t>pass 31</a:t>
+            </a:r>
+          </a:p>
+          <a:p>
+            <a:pPr algn="l">
+              <a:spcAft>
+                <a:spcPts val="0"/>
+              </a:spcAft>
+            </a:pPr>
+            <a:r>
+              <a:rPr sz="1400" b="0">
+                <a:solidFill>
+                  <a:srgbClr val="E6EAF2"/>
+                </a:solidFill>
+                <a:latin typeface="Consolas"/>
+              </a:rPr>
+              <a:t>fail 0</a:t>
+            </a:r>
+          </a:p>
+        </p:txBody>
+      </p:sp>
     </p:spTree>
   </p:cSld>
   <p:clrMapOvr>
@@ -3871,7 +3635,7 @@
                 </a:solidFill>
                 <a:latin typeface="Arial"/>
               </a:rPr>
-              <a:t>Demonstration</a:t>
+              <a:t>Results</a:t>
             </a:r>
           </a:p>
         </p:txBody>
@@ -3926,7 +3690,7 @@
                 </a:solidFill>
                 <a:latin typeface="Georgia"/>
               </a:rPr>
-              <a:t>Live Demo Flow</a:t>
+              <a:t>Scope Achieved Against Phase 1</a:t>
             </a:r>
           </a:p>
         </p:txBody>
@@ -3986,712 +3750,645 @@
           </a:p>
         </p:txBody>
       </p:sp>
-      <p:sp>
-        <p:nvSpPr>
-          <p:cNvPr id="5" name="Rounded Rectangle 4"/>
-          <p:cNvSpPr/>
+      <p:graphicFrame>
+        <p:nvGraphicFramePr>
+          <p:cNvPr id="5" name="Table 4"/>
+          <p:cNvGraphicFramePr>
+            <a:graphicFrameLocks noGrp="1"/>
+          </p:cNvGraphicFramePr>
           <p:nvPr/>
-        </p:nvSpPr>
-        <p:spPr>
-          <a:xfrm>
-            <a:off x="587044" y="1371600"/>
-            <a:ext cx="1874519" cy="777240"/>
-          </a:xfrm>
-          <a:prstGeom prst="roundRect">
-            <a:avLst/>
-          </a:prstGeom>
-          <a:solidFill>
-            <a:srgbClr val="14284B"/>
-          </a:solidFill>
-          <a:ln>
-            <a:noFill/>
-          </a:ln>
-          <a:effectLst/>
-        </p:spPr>
-        <p:style>
-          <a:lnRef idx="1">
-            <a:schemeClr val="accent1"/>
-          </a:lnRef>
-          <a:fillRef idx="3">
-            <a:schemeClr val="accent1"/>
-          </a:fillRef>
-          <a:effectRef idx="2">
-            <a:schemeClr val="accent1"/>
-          </a:effectRef>
-          <a:fontRef idx="minor">
-            <a:schemeClr val="lt1"/>
-          </a:fontRef>
-        </p:style>
-        <p:txBody>
-          <a:bodyPr rtlCol="0" anchor="ctr" wrap="square" lIns="109728" rIns="109728"/>
-          <a:lstStyle/>
-          <a:p>
-            <a:pPr algn="ctr">
-              <a:spcAft>
-                <a:spcPts val="0"/>
-              </a:spcAft>
-            </a:pPr>
-            <a:r>
-              <a:rPr sz="1100" b="1">
-                <a:solidFill>
-                  <a:srgbClr val="C9962B"/>
-                </a:solidFill>
-                <a:latin typeface="Arial"/>
-              </a:rPr>
-              <a:t>STEP 1</a:t>
-            </a:r>
-          </a:p>
-          <a:p>
-            <a:pPr algn="ctr">
-              <a:spcAft>
-                <a:spcPts val="400"/>
-              </a:spcAft>
-            </a:pPr>
-            <a:r>
-              <a:rPr sz="1300" b="1">
-                <a:solidFill>
-                  <a:srgbClr val="FFFFFF"/>
-                </a:solidFill>
-                <a:latin typeface="Arial"/>
-              </a:rPr>
-              <a:t>Sign up</a:t>
-            </a:r>
-          </a:p>
-        </p:txBody>
-      </p:sp>
-      <p:sp>
-        <p:nvSpPr>
-          <p:cNvPr id="6" name="Rectangle 5"/>
-          <p:cNvSpPr/>
-          <p:nvPr/>
-        </p:nvSpPr>
-        <p:spPr>
-          <a:xfrm>
-            <a:off x="2461564" y="1572768"/>
-            <a:ext cx="411480" cy="365760"/>
-          </a:xfrm>
-          <a:prstGeom prst="rect">
-            <a:avLst/>
-          </a:prstGeom>
-          <a:noFill/>
-          <a:ln>
-            <a:noFill/>
-          </a:ln>
-          <a:effectLst/>
-        </p:spPr>
-        <p:style>
-          <a:lnRef idx="1">
-            <a:schemeClr val="accent1"/>
-          </a:lnRef>
-          <a:fillRef idx="3">
-            <a:schemeClr val="accent1"/>
-          </a:fillRef>
-          <a:effectRef idx="2">
-            <a:schemeClr val="accent1"/>
-          </a:effectRef>
-          <a:fontRef idx="minor">
-            <a:schemeClr val="lt1"/>
-          </a:fontRef>
-        </p:style>
-        <p:txBody>
-          <a:bodyPr rtlCol="0" anchor="t" wrap="square" lIns="0" rIns="0"/>
-          <a:lstStyle/>
-          <a:p>
-            <a:pPr algn="ctr">
-              <a:spcAft>
-                <a:spcPts val="400"/>
-              </a:spcAft>
-            </a:pPr>
-            <a:r>
-              <a:rPr sz="1800" b="0">
-                <a:solidFill>
-                  <a:srgbClr val="C9962B"/>
-                </a:solidFill>
-                <a:latin typeface="Arial"/>
-              </a:rPr>
-              <a:t>→</a:t>
-            </a:r>
-          </a:p>
-        </p:txBody>
-      </p:sp>
-      <p:sp>
-        <p:nvSpPr>
-          <p:cNvPr id="7" name="Rounded Rectangle 6"/>
-          <p:cNvSpPr/>
-          <p:nvPr/>
-        </p:nvSpPr>
-        <p:spPr>
-          <a:xfrm>
-            <a:off x="2873044" y="1371600"/>
-            <a:ext cx="1874519" cy="777240"/>
-          </a:xfrm>
-          <a:prstGeom prst="roundRect">
-            <a:avLst/>
-          </a:prstGeom>
-          <a:solidFill>
-            <a:srgbClr val="14284B"/>
-          </a:solidFill>
-          <a:ln>
-            <a:noFill/>
-          </a:ln>
-          <a:effectLst/>
-        </p:spPr>
-        <p:style>
-          <a:lnRef idx="1">
-            <a:schemeClr val="accent1"/>
-          </a:lnRef>
-          <a:fillRef idx="3">
-            <a:schemeClr val="accent1"/>
-          </a:fillRef>
-          <a:effectRef idx="2">
-            <a:schemeClr val="accent1"/>
-          </a:effectRef>
-          <a:fontRef idx="minor">
-            <a:schemeClr val="lt1"/>
-          </a:fontRef>
-        </p:style>
-        <p:txBody>
-          <a:bodyPr rtlCol="0" anchor="ctr" wrap="square" lIns="109728" rIns="109728"/>
-          <a:lstStyle/>
-          <a:p>
-            <a:pPr algn="ctr">
-              <a:spcAft>
-                <a:spcPts val="0"/>
-              </a:spcAft>
-            </a:pPr>
-            <a:r>
-              <a:rPr sz="1100" b="1">
-                <a:solidFill>
-                  <a:srgbClr val="C9962B"/>
-                </a:solidFill>
-                <a:latin typeface="Arial"/>
-              </a:rPr>
-              <a:t>STEP 2</a:t>
-            </a:r>
-          </a:p>
-          <a:p>
-            <a:pPr algn="ctr">
-              <a:spcAft>
-                <a:spcPts val="400"/>
-              </a:spcAft>
-            </a:pPr>
-            <a:r>
-              <a:rPr sz="1300" b="1">
-                <a:solidFill>
-                  <a:srgbClr val="FFFFFF"/>
-                </a:solidFill>
-                <a:latin typeface="Arial"/>
-              </a:rPr>
-              <a:t>Take a quiz</a:t>
-            </a:r>
-          </a:p>
-        </p:txBody>
-      </p:sp>
-      <p:sp>
-        <p:nvSpPr>
-          <p:cNvPr id="8" name="Rectangle 7"/>
-          <p:cNvSpPr/>
-          <p:nvPr/>
-        </p:nvSpPr>
-        <p:spPr>
-          <a:xfrm>
-            <a:off x="4747564" y="1572768"/>
-            <a:ext cx="411480" cy="365760"/>
-          </a:xfrm>
-          <a:prstGeom prst="rect">
-            <a:avLst/>
-          </a:prstGeom>
-          <a:noFill/>
-          <a:ln>
-            <a:noFill/>
-          </a:ln>
-          <a:effectLst/>
-        </p:spPr>
-        <p:style>
-          <a:lnRef idx="1">
-            <a:schemeClr val="accent1"/>
-          </a:lnRef>
-          <a:fillRef idx="3">
-            <a:schemeClr val="accent1"/>
-          </a:fillRef>
-          <a:effectRef idx="2">
-            <a:schemeClr val="accent1"/>
-          </a:effectRef>
-          <a:fontRef idx="minor">
-            <a:schemeClr val="lt1"/>
-          </a:fontRef>
-        </p:style>
-        <p:txBody>
-          <a:bodyPr rtlCol="0" anchor="t" wrap="square" lIns="0" rIns="0"/>
-          <a:lstStyle/>
-          <a:p>
-            <a:pPr algn="ctr">
-              <a:spcAft>
-                <a:spcPts val="400"/>
-              </a:spcAft>
-            </a:pPr>
-            <a:r>
-              <a:rPr sz="1800" b="0">
-                <a:solidFill>
-                  <a:srgbClr val="C9962B"/>
-                </a:solidFill>
-                <a:latin typeface="Arial"/>
-              </a:rPr>
-              <a:t>→</a:t>
-            </a:r>
-          </a:p>
-        </p:txBody>
-      </p:sp>
-      <p:sp>
-        <p:nvSpPr>
-          <p:cNvPr id="9" name="Rounded Rectangle 8"/>
-          <p:cNvSpPr/>
-          <p:nvPr/>
-        </p:nvSpPr>
-        <p:spPr>
-          <a:xfrm>
-            <a:off x="5159044" y="1371600"/>
-            <a:ext cx="1874519" cy="777240"/>
-          </a:xfrm>
-          <a:prstGeom prst="roundRect">
-            <a:avLst/>
-          </a:prstGeom>
-          <a:solidFill>
-            <a:srgbClr val="14284B"/>
-          </a:solidFill>
-          <a:ln>
-            <a:noFill/>
-          </a:ln>
-          <a:effectLst/>
-        </p:spPr>
-        <p:style>
-          <a:lnRef idx="1">
-            <a:schemeClr val="accent1"/>
-          </a:lnRef>
-          <a:fillRef idx="3">
-            <a:schemeClr val="accent1"/>
-          </a:fillRef>
-          <a:effectRef idx="2">
-            <a:schemeClr val="accent1"/>
-          </a:effectRef>
-          <a:fontRef idx="minor">
-            <a:schemeClr val="lt1"/>
-          </a:fontRef>
-        </p:style>
-        <p:txBody>
-          <a:bodyPr rtlCol="0" anchor="ctr" wrap="square" lIns="109728" rIns="109728"/>
-          <a:lstStyle/>
-          <a:p>
-            <a:pPr algn="ctr">
-              <a:spcAft>
-                <a:spcPts val="0"/>
-              </a:spcAft>
-            </a:pPr>
-            <a:r>
-              <a:rPr sz="1100" b="1">
-                <a:solidFill>
-                  <a:srgbClr val="C9962B"/>
-                </a:solidFill>
-                <a:latin typeface="Arial"/>
-              </a:rPr>
-              <a:t>STEP 3</a:t>
-            </a:r>
-          </a:p>
-          <a:p>
-            <a:pPr algn="ctr">
-              <a:spcAft>
-                <a:spcPts val="400"/>
-              </a:spcAft>
-            </a:pPr>
-            <a:r>
-              <a:rPr sz="1300" b="1">
-                <a:solidFill>
-                  <a:srgbClr val="FFFFFF"/>
-                </a:solidFill>
-                <a:latin typeface="Arial"/>
-              </a:rPr>
-              <a:t>See proficiency</a:t>
-            </a:r>
-          </a:p>
-        </p:txBody>
-      </p:sp>
-      <p:sp>
-        <p:nvSpPr>
-          <p:cNvPr id="10" name="Rectangle 9"/>
-          <p:cNvSpPr/>
-          <p:nvPr/>
-        </p:nvSpPr>
-        <p:spPr>
-          <a:xfrm>
-            <a:off x="7033564" y="1572768"/>
-            <a:ext cx="411480" cy="365760"/>
-          </a:xfrm>
-          <a:prstGeom prst="rect">
-            <a:avLst/>
-          </a:prstGeom>
-          <a:noFill/>
-          <a:ln>
-            <a:noFill/>
-          </a:ln>
-          <a:effectLst/>
-        </p:spPr>
-        <p:style>
-          <a:lnRef idx="1">
-            <a:schemeClr val="accent1"/>
-          </a:lnRef>
-          <a:fillRef idx="3">
-            <a:schemeClr val="accent1"/>
-          </a:fillRef>
-          <a:effectRef idx="2">
-            <a:schemeClr val="accent1"/>
-          </a:effectRef>
-          <a:fontRef idx="minor">
-            <a:schemeClr val="lt1"/>
-          </a:fontRef>
-        </p:style>
-        <p:txBody>
-          <a:bodyPr rtlCol="0" anchor="t" wrap="square" lIns="0" rIns="0"/>
-          <a:lstStyle/>
-          <a:p>
-            <a:pPr algn="ctr">
-              <a:spcAft>
-                <a:spcPts val="400"/>
-              </a:spcAft>
-            </a:pPr>
-            <a:r>
-              <a:rPr sz="1800" b="0">
-                <a:solidFill>
-                  <a:srgbClr val="C9962B"/>
-                </a:solidFill>
-                <a:latin typeface="Arial"/>
-              </a:rPr>
-              <a:t>→</a:t>
-            </a:r>
-          </a:p>
-        </p:txBody>
-      </p:sp>
-      <p:sp>
-        <p:nvSpPr>
-          <p:cNvPr id="11" name="Rounded Rectangle 10"/>
-          <p:cNvSpPr/>
-          <p:nvPr/>
-        </p:nvSpPr>
-        <p:spPr>
-          <a:xfrm>
-            <a:off x="7445044" y="1371600"/>
-            <a:ext cx="1874519" cy="777240"/>
-          </a:xfrm>
-          <a:prstGeom prst="roundRect">
-            <a:avLst/>
-          </a:prstGeom>
-          <a:solidFill>
-            <a:srgbClr val="14284B"/>
-          </a:solidFill>
-          <a:ln>
-            <a:noFill/>
-          </a:ln>
-          <a:effectLst/>
-        </p:spPr>
-        <p:style>
-          <a:lnRef idx="1">
-            <a:schemeClr val="accent1"/>
-          </a:lnRef>
-          <a:fillRef idx="3">
-            <a:schemeClr val="accent1"/>
-          </a:fillRef>
-          <a:effectRef idx="2">
-            <a:schemeClr val="accent1"/>
-          </a:effectRef>
-          <a:fontRef idx="minor">
-            <a:schemeClr val="lt1"/>
-          </a:fontRef>
-        </p:style>
-        <p:txBody>
-          <a:bodyPr rtlCol="0" anchor="ctr" wrap="square" lIns="109728" rIns="109728"/>
-          <a:lstStyle/>
-          <a:p>
-            <a:pPr algn="ctr">
-              <a:spcAft>
-                <a:spcPts val="0"/>
-              </a:spcAft>
-            </a:pPr>
-            <a:r>
-              <a:rPr sz="1100" b="1">
-                <a:solidFill>
-                  <a:srgbClr val="C9962B"/>
-                </a:solidFill>
-                <a:latin typeface="Arial"/>
-              </a:rPr>
-              <a:t>STEP 4</a:t>
-            </a:r>
-          </a:p>
-          <a:p>
-            <a:pPr algn="ctr">
-              <a:spcAft>
-                <a:spcPts val="400"/>
-              </a:spcAft>
-            </a:pPr>
-            <a:r>
-              <a:rPr sz="1300" b="1">
-                <a:solidFill>
-                  <a:srgbClr val="FFFFFF"/>
-                </a:solidFill>
-                <a:latin typeface="Arial"/>
-              </a:rPr>
-              <a:t>Refresh recommendations</a:t>
-            </a:r>
-          </a:p>
-        </p:txBody>
-      </p:sp>
-      <p:sp>
-        <p:nvSpPr>
-          <p:cNvPr id="12" name="Rectangle 11"/>
-          <p:cNvSpPr/>
-          <p:nvPr/>
-        </p:nvSpPr>
-        <p:spPr>
-          <a:xfrm>
-            <a:off x="9319564" y="1572768"/>
-            <a:ext cx="411480" cy="365760"/>
-          </a:xfrm>
-          <a:prstGeom prst="rect">
-            <a:avLst/>
-          </a:prstGeom>
-          <a:noFill/>
-          <a:ln>
-            <a:noFill/>
-          </a:ln>
-          <a:effectLst/>
-        </p:spPr>
-        <p:style>
-          <a:lnRef idx="1">
-            <a:schemeClr val="accent1"/>
-          </a:lnRef>
-          <a:fillRef idx="3">
-            <a:schemeClr val="accent1"/>
-          </a:fillRef>
-          <a:effectRef idx="2">
-            <a:schemeClr val="accent1"/>
-          </a:effectRef>
-          <a:fontRef idx="minor">
-            <a:schemeClr val="lt1"/>
-          </a:fontRef>
-        </p:style>
-        <p:txBody>
-          <a:bodyPr rtlCol="0" anchor="t" wrap="square" lIns="0" rIns="0"/>
-          <a:lstStyle/>
-          <a:p>
-            <a:pPr algn="ctr">
-              <a:spcAft>
-                <a:spcPts val="400"/>
-              </a:spcAft>
-            </a:pPr>
-            <a:r>
-              <a:rPr sz="1800" b="0">
-                <a:solidFill>
-                  <a:srgbClr val="C9962B"/>
-                </a:solidFill>
-                <a:latin typeface="Arial"/>
-              </a:rPr>
-              <a:t>→</a:t>
-            </a:r>
-          </a:p>
-        </p:txBody>
-      </p:sp>
-      <p:sp>
-        <p:nvSpPr>
-          <p:cNvPr id="13" name="Rounded Rectangle 12"/>
-          <p:cNvSpPr/>
-          <p:nvPr/>
-        </p:nvSpPr>
-        <p:spPr>
-          <a:xfrm>
-            <a:off x="9731044" y="1371600"/>
-            <a:ext cx="1874519" cy="777240"/>
-          </a:xfrm>
-          <a:prstGeom prst="roundRect">
-            <a:avLst/>
-          </a:prstGeom>
-          <a:solidFill>
-            <a:srgbClr val="14284B"/>
-          </a:solidFill>
-          <a:ln>
-            <a:noFill/>
-          </a:ln>
-          <a:effectLst/>
-        </p:spPr>
-        <p:style>
-          <a:lnRef idx="1">
-            <a:schemeClr val="accent1"/>
-          </a:lnRef>
-          <a:fillRef idx="3">
-            <a:schemeClr val="accent1"/>
-          </a:fillRef>
-          <a:effectRef idx="2">
-            <a:schemeClr val="accent1"/>
-          </a:effectRef>
-          <a:fontRef idx="minor">
-            <a:schemeClr val="lt1"/>
-          </a:fontRef>
-        </p:style>
-        <p:txBody>
-          <a:bodyPr rtlCol="0" anchor="ctr" wrap="square" lIns="109728" rIns="109728"/>
-          <a:lstStyle/>
-          <a:p>
-            <a:pPr algn="ctr">
-              <a:spcAft>
-                <a:spcPts val="0"/>
-              </a:spcAft>
-            </a:pPr>
-            <a:r>
-              <a:rPr sz="1100" b="1">
-                <a:solidFill>
-                  <a:srgbClr val="C9962B"/>
-                </a:solidFill>
-                <a:latin typeface="Arial"/>
-              </a:rPr>
-              <a:t>STEP 5</a:t>
-            </a:r>
-          </a:p>
-          <a:p>
-            <a:pPr algn="ctr">
-              <a:spcAft>
-                <a:spcPts val="400"/>
-              </a:spcAft>
-            </a:pPr>
-            <a:r>
-              <a:rPr sz="1300" b="1">
-                <a:solidFill>
-                  <a:srgbClr val="FFFFFF"/>
-                </a:solidFill>
-                <a:latin typeface="Arial"/>
-              </a:rPr>
-              <a:t>Leaderboard</a:t>
-            </a:r>
-          </a:p>
-        </p:txBody>
-      </p:sp>
-      <p:sp>
-        <p:nvSpPr>
-          <p:cNvPr id="14" name="Rectangle 13"/>
-          <p:cNvSpPr/>
-          <p:nvPr/>
-        </p:nvSpPr>
-        <p:spPr>
-          <a:xfrm>
-            <a:off x="609904" y="2651760"/>
-            <a:ext cx="10972800" cy="3291840"/>
-          </a:xfrm>
-          <a:prstGeom prst="rect">
-            <a:avLst/>
-          </a:prstGeom>
-          <a:solidFill>
-            <a:srgbClr val="F3F4F6"/>
-          </a:solidFill>
-          <a:ln>
-            <a:noFill/>
-          </a:ln>
-          <a:effectLst/>
-        </p:spPr>
-        <p:style>
-          <a:lnRef idx="1">
-            <a:schemeClr val="accent1"/>
-          </a:lnRef>
-          <a:fillRef idx="3">
-            <a:schemeClr val="accent1"/>
-          </a:fillRef>
-          <a:effectRef idx="2">
-            <a:schemeClr val="accent1"/>
-          </a:effectRef>
-          <a:fontRef idx="minor">
-            <a:schemeClr val="lt1"/>
-          </a:fontRef>
-        </p:style>
-        <p:txBody>
-          <a:bodyPr rtlCol="0" anchor="t" wrap="square" lIns="201168" rIns="201168"/>
-          <a:lstStyle/>
-          <a:p>
-            <a:pPr algn="l">
-              <a:spcAft>
-                <a:spcPts val="400"/>
-              </a:spcAft>
-            </a:pPr>
-            <a:r>
-              <a:rPr sz="1600" b="1">
-                <a:solidFill>
-                  <a:srgbClr val="14284B"/>
-                </a:solidFill>
-                <a:latin typeface="Arial"/>
-              </a:rPr>
-              <a:t>Then show the database side</a:t>
-            </a:r>
-          </a:p>
-          <a:p>
-            <a:pPr algn="l">
-              <a:spcAft>
-                <a:spcPts val="400"/>
-              </a:spcAft>
-            </a:pPr>
-            <a:r>
-              <a:rPr sz="1400" b="0">
-                <a:solidFill>
-                  <a:srgbClr val="1F2933"/>
-                </a:solidFill>
-                <a:latin typeface="Arial"/>
-              </a:rPr>
-              <a:t>psql: SELECT the new attempt and the updated topic_proficiency row.</a:t>
-            </a:r>
-          </a:p>
-          <a:p>
-            <a:pPr algn="l">
-              <a:spcAft>
-                <a:spcPts val="400"/>
-              </a:spcAft>
-            </a:pPr>
-            <a:r>
-              <a:rPr sz="1400" b="0">
-                <a:solidFill>
-                  <a:srgbClr val="1F2933"/>
-                </a:solidFill>
-                <a:latin typeface="Arial"/>
-              </a:rPr>
-              <a:t>Topics: add, edit, delete, then try to delete Arrays to show the trigger message.</a:t>
-            </a:r>
-          </a:p>
-          <a:p>
-            <a:pPr algn="l">
-              <a:spcAft>
-                <a:spcPts val="400"/>
-              </a:spcAft>
-            </a:pPr>
-            <a:r>
-              <a:rPr sz="1400" b="0">
-                <a:solidFill>
-                  <a:srgbClr val="1F2933"/>
-                </a:solidFill>
-                <a:latin typeface="Arial"/>
-              </a:rPr>
-              <a:t>Java: run JdbcDemo --demo and point out the same functions being called.</a:t>
-            </a:r>
-          </a:p>
-          <a:p>
-            <a:pPr algn="l">
-              <a:spcAft>
-                <a:spcPts val="400"/>
-              </a:spcAft>
-            </a:pPr>
-            <a:r>
-              <a:rPr sz="1400" b="0">
-                <a:solidFill>
-                  <a:srgbClr val="1F2933"/>
-                </a:solidFill>
-                <a:latin typeface="Arial"/>
-              </a:rPr>
-              <a:t>Terminal: npm test, 31 of 31 passing.</a:t>
-            </a:r>
-          </a:p>
-        </p:txBody>
-      </p:sp>
+        </p:nvGraphicFramePr>
+        <p:xfrm>
+          <a:off x="609904" y="1280160"/>
+          <a:ext cx="10972800" cy="4114800"/>
+        </p:xfrm>
+        <a:graphic>
+          <a:graphicData uri="http://schemas.openxmlformats.org/drawingml/2006/table">
+            <a:tbl>
+              <a:tblPr firstRow="1" bandRow="1">
+                <a:tableStyleId>{5C22544A-7EE6-4342-B048-85BDC9FD1C3A}</a:tableStyleId>
+              </a:tblPr>
+              <a:tblGrid>
+                <a:gridCol w="3657600"/>
+                <a:gridCol w="1463040"/>
+                <a:gridCol w="5852160"/>
+              </a:tblGrid>
+              <a:tr h="457200">
+                <a:tc>
+                  <a:txBody>
+                    <a:bodyPr/>
+                    <a:lstStyle/>
+                    <a:p>
+                      <a:r>
+                        <a:rPr sz="1200" b="1">
+                          <a:solidFill>
+                            <a:srgbClr val="000000"/>
+                          </a:solidFill>
+                          <a:latin typeface="Arial"/>
+                        </a:rPr>
+                        <a:t>Module (Phase 1 scope)</a:t>
+                      </a:r>
+                    </a:p>
+                  </a:txBody>
+                  <a:tcPr marT="36576" marB="36576">
+                    <a:solidFill>
+                      <a:srgbClr val="E2E2DC"/>
+                    </a:solidFill>
+                  </a:tcPr>
+                </a:tc>
+                <a:tc>
+                  <a:txBody>
+                    <a:bodyPr/>
+                    <a:lstStyle/>
+                    <a:p>
+                      <a:r>
+                        <a:rPr sz="1200" b="1">
+                          <a:solidFill>
+                            <a:srgbClr val="000000"/>
+                          </a:solidFill>
+                          <a:latin typeface="Arial"/>
+                        </a:rPr>
+                        <a:t>Status</a:t>
+                      </a:r>
+                    </a:p>
+                  </a:txBody>
+                  <a:tcPr marT="36576" marB="36576">
+                    <a:solidFill>
+                      <a:srgbClr val="E2E2DC"/>
+                    </a:solidFill>
+                  </a:tcPr>
+                </a:tc>
+                <a:tc>
+                  <a:txBody>
+                    <a:bodyPr/>
+                    <a:lstStyle/>
+                    <a:p>
+                      <a:r>
+                        <a:rPr sz="1200" b="1">
+                          <a:solidFill>
+                            <a:srgbClr val="000000"/>
+                          </a:solidFill>
+                          <a:latin typeface="Arial"/>
+                        </a:rPr>
+                        <a:t>Remarks</a:t>
+                      </a:r>
+                    </a:p>
+                  </a:txBody>
+                  <a:tcPr marT="36576" marB="36576">
+                    <a:solidFill>
+                      <a:srgbClr val="E2E2DC"/>
+                    </a:solidFill>
+                  </a:tcPr>
+                </a:tc>
+              </a:tr>
+              <a:tr h="457200">
+                <a:tc>
+                  <a:txBody>
+                    <a:bodyPr/>
+                    <a:lstStyle/>
+                    <a:p>
+                      <a:r>
+                        <a:rPr sz="1200" b="0">
+                          <a:solidFill>
+                            <a:srgbClr val="1F2933"/>
+                          </a:solidFill>
+                          <a:latin typeface="Arial"/>
+                        </a:rPr>
+                        <a:t>Topics, quizzes, projects, questions</a:t>
+                      </a:r>
+                    </a:p>
+                  </a:txBody>
+                  <a:tcPr marT="36576" marB="36576">
+                    <a:solidFill>
+                      <a:srgbClr val="FFFFFF"/>
+                    </a:solidFill>
+                  </a:tcPr>
+                </a:tc>
+                <a:tc>
+                  <a:txBody>
+                    <a:bodyPr/>
+                    <a:lstStyle/>
+                    <a:p>
+                      <a:r>
+                        <a:rPr sz="1200" b="0">
+                          <a:solidFill>
+                            <a:srgbClr val="1F2933"/>
+                          </a:solidFill>
+                          <a:latin typeface="Arial"/>
+                        </a:rPr>
+                        <a:t>Completed</a:t>
+                      </a:r>
+                    </a:p>
+                  </a:txBody>
+                  <a:tcPr marT="36576" marB="36576">
+                    <a:solidFill>
+                      <a:srgbClr val="FFFFFF"/>
+                    </a:solidFill>
+                  </a:tcPr>
+                </a:tc>
+                <a:tc>
+                  <a:txBody>
+                    <a:bodyPr/>
+                    <a:lstStyle/>
+                    <a:p>
+                      <a:r>
+                        <a:rPr sz="1200" b="0">
+                          <a:solidFill>
+                            <a:srgbClr val="1F2933"/>
+                          </a:solidFill>
+                          <a:latin typeface="Arial"/>
+                        </a:rPr>
+                        <a:t>Full CRUD from the front end</a:t>
+                      </a:r>
+                    </a:p>
+                  </a:txBody>
+                  <a:tcPr marT="36576" marB="36576">
+                    <a:solidFill>
+                      <a:srgbClr val="FFFFFF"/>
+                    </a:solidFill>
+                  </a:tcPr>
+                </a:tc>
+              </a:tr>
+              <a:tr h="457200">
+                <a:tc>
+                  <a:txBody>
+                    <a:bodyPr/>
+                    <a:lstStyle/>
+                    <a:p>
+                      <a:r>
+                        <a:rPr sz="1200" b="0">
+                          <a:solidFill>
+                            <a:srgbClr val="1F2933"/>
+                          </a:solidFill>
+                          <a:latin typeface="Arial"/>
+                        </a:rPr>
+                        <a:t>Quiz taking and grading</a:t>
+                      </a:r>
+                    </a:p>
+                  </a:txBody>
+                  <a:tcPr marT="36576" marB="36576">
+                    <a:solidFill>
+                      <a:srgbClr val="FFFFFF"/>
+                    </a:solidFill>
+                  </a:tcPr>
+                </a:tc>
+                <a:tc>
+                  <a:txBody>
+                    <a:bodyPr/>
+                    <a:lstStyle/>
+                    <a:p>
+                      <a:r>
+                        <a:rPr sz="1200" b="0">
+                          <a:solidFill>
+                            <a:srgbClr val="1F2933"/>
+                          </a:solidFill>
+                          <a:latin typeface="Arial"/>
+                        </a:rPr>
+                        <a:t>Completed</a:t>
+                      </a:r>
+                    </a:p>
+                  </a:txBody>
+                  <a:tcPr marT="36576" marB="36576">
+                    <a:solidFill>
+                      <a:srgbClr val="FFFFFF"/>
+                    </a:solidFill>
+                  </a:tcPr>
+                </a:tc>
+                <a:tc>
+                  <a:txBody>
+                    <a:bodyPr/>
+                    <a:lstStyle/>
+                    <a:p>
+                      <a:r>
+                        <a:rPr sz="1200" b="0">
+                          <a:solidFill>
+                            <a:srgbClr val="1F2933"/>
+                          </a:solidFill>
+                          <a:latin typeface="Arial"/>
+                        </a:rPr>
+                        <a:t>grade_quiz() and record_attempt() in one transaction</a:t>
+                      </a:r>
+                    </a:p>
+                  </a:txBody>
+                  <a:tcPr marT="36576" marB="36576">
+                    <a:solidFill>
+                      <a:srgbClr val="FFFFFF"/>
+                    </a:solidFill>
+                  </a:tcPr>
+                </a:tc>
+              </a:tr>
+              <a:tr h="457200">
+                <a:tc>
+                  <a:txBody>
+                    <a:bodyPr/>
+                    <a:lstStyle/>
+                    <a:p>
+                      <a:r>
+                        <a:rPr sz="1200" b="0">
+                          <a:solidFill>
+                            <a:srgbClr val="1F2933"/>
+                          </a:solidFill>
+                          <a:latin typeface="Arial"/>
+                        </a:rPr>
+                        <a:t>Attempt history and topic proficiency</a:t>
+                      </a:r>
+                    </a:p>
+                  </a:txBody>
+                  <a:tcPr marT="36576" marB="36576">
+                    <a:solidFill>
+                      <a:srgbClr val="FFFFFF"/>
+                    </a:solidFill>
+                  </a:tcPr>
+                </a:tc>
+                <a:tc>
+                  <a:txBody>
+                    <a:bodyPr/>
+                    <a:lstStyle/>
+                    <a:p>
+                      <a:r>
+                        <a:rPr sz="1200" b="0">
+                          <a:solidFill>
+                            <a:srgbClr val="1F2933"/>
+                          </a:solidFill>
+                          <a:latin typeface="Arial"/>
+                        </a:rPr>
+                        <a:t>Completed</a:t>
+                      </a:r>
+                    </a:p>
+                  </a:txBody>
+                  <a:tcPr marT="36576" marB="36576">
+                    <a:solidFill>
+                      <a:srgbClr val="FFFFFF"/>
+                    </a:solidFill>
+                  </a:tcPr>
+                </a:tc>
+                <a:tc>
+                  <a:txBody>
+                    <a:bodyPr/>
+                    <a:lstStyle/>
+                    <a:p>
+                      <a:r>
+                        <a:rPr sz="1200" b="0">
+                          <a:solidFill>
+                            <a:srgbClr val="1F2933"/>
+                          </a:solidFill>
+                          <a:latin typeface="Arial"/>
+                        </a:rPr>
+                        <a:t>Maintained by trigger trg_update_proficiency</a:t>
+                      </a:r>
+                    </a:p>
+                  </a:txBody>
+                  <a:tcPr marT="36576" marB="36576">
+                    <a:solidFill>
+                      <a:srgbClr val="FFFFFF"/>
+                    </a:solidFill>
+                  </a:tcPr>
+                </a:tc>
+              </a:tr>
+              <a:tr h="457200">
+                <a:tc>
+                  <a:txBody>
+                    <a:bodyPr/>
+                    <a:lstStyle/>
+                    <a:p>
+                      <a:r>
+                        <a:rPr sz="1200" b="0">
+                          <a:solidFill>
+                            <a:srgbClr val="1F2933"/>
+                          </a:solidFill>
+                          <a:latin typeface="Arial"/>
+                        </a:rPr>
+                        <a:t>Recommendations</a:t>
+                      </a:r>
+                    </a:p>
+                  </a:txBody>
+                  <a:tcPr marT="36576" marB="36576">
+                    <a:solidFill>
+                      <a:srgbClr val="FFFFFF"/>
+                    </a:solidFill>
+                  </a:tcPr>
+                </a:tc>
+                <a:tc>
+                  <a:txBody>
+                    <a:bodyPr/>
+                    <a:lstStyle/>
+                    <a:p>
+                      <a:r>
+                        <a:rPr sz="1200" b="0">
+                          <a:solidFill>
+                            <a:srgbClr val="1F2933"/>
+                          </a:solidFill>
+                          <a:latin typeface="Arial"/>
+                        </a:rPr>
+                        <a:t>Completed</a:t>
+                      </a:r>
+                    </a:p>
+                  </a:txBody>
+                  <a:tcPr marT="36576" marB="36576">
+                    <a:solidFill>
+                      <a:srgbClr val="FFFFFF"/>
+                    </a:solidFill>
+                  </a:tcPr>
+                </a:tc>
+                <a:tc>
+                  <a:txBody>
+                    <a:bodyPr/>
+                    <a:lstStyle/>
+                    <a:p>
+                      <a:r>
+                        <a:rPr sz="1200" b="0">
+                          <a:solidFill>
+                            <a:srgbClr val="1F2933"/>
+                          </a:solidFill>
+                          <a:latin typeface="Arial"/>
+                        </a:rPr>
+                        <a:t>Weak-topic rule plus pgvector similarity (replaces Qdrant)</a:t>
+                      </a:r>
+                    </a:p>
+                  </a:txBody>
+                  <a:tcPr marT="36576" marB="36576">
+                    <a:solidFill>
+                      <a:srgbClr val="FFFFFF"/>
+                    </a:solidFill>
+                  </a:tcPr>
+                </a:tc>
+              </a:tr>
+              <a:tr h="457200">
+                <a:tc>
+                  <a:txBody>
+                    <a:bodyPr/>
+                    <a:lstStyle/>
+                    <a:p>
+                      <a:r>
+                        <a:rPr sz="1200" b="0">
+                          <a:solidFill>
+                            <a:srgbClr val="1F2933"/>
+                          </a:solidFill>
+                          <a:latin typeface="Arial"/>
+                        </a:rPr>
+                        <a:t>Leaderboard</a:t>
+                      </a:r>
+                    </a:p>
+                  </a:txBody>
+                  <a:tcPr marT="36576" marB="36576">
+                    <a:solidFill>
+                      <a:srgbClr val="FFFFFF"/>
+                    </a:solidFill>
+                  </a:tcPr>
+                </a:tc>
+                <a:tc>
+                  <a:txBody>
+                    <a:bodyPr/>
+                    <a:lstStyle/>
+                    <a:p>
+                      <a:r>
+                        <a:rPr sz="1200" b="0">
+                          <a:solidFill>
+                            <a:srgbClr val="1F2933"/>
+                          </a:solidFill>
+                          <a:latin typeface="Arial"/>
+                        </a:rPr>
+                        <a:t>Completed</a:t>
+                      </a:r>
+                    </a:p>
+                  </a:txBody>
+                  <a:tcPr marT="36576" marB="36576">
+                    <a:solidFill>
+                      <a:srgbClr val="FFFFFF"/>
+                    </a:solidFill>
+                  </a:tcPr>
+                </a:tc>
+                <a:tc>
+                  <a:txBody>
+                    <a:bodyPr/>
+                    <a:lstStyle/>
+                    <a:p>
+                      <a:r>
+                        <a:rPr sz="1200" b="0">
+                          <a:solidFill>
+                            <a:srgbClr val="1F2933"/>
+                          </a:solidFill>
+                          <a:latin typeface="Arial"/>
+                        </a:rPr>
+                        <a:t>View v_leaderboard</a:t>
+                      </a:r>
+                    </a:p>
+                  </a:txBody>
+                  <a:tcPr marT="36576" marB="36576">
+                    <a:solidFill>
+                      <a:srgbClr val="FFFFFF"/>
+                    </a:solidFill>
+                  </a:tcPr>
+                </a:tc>
+              </a:tr>
+              <a:tr h="457200">
+                <a:tc>
+                  <a:txBody>
+                    <a:bodyPr/>
+                    <a:lstStyle/>
+                    <a:p>
+                      <a:r>
+                        <a:rPr sz="1200" b="0">
+                          <a:solidFill>
+                            <a:srgbClr val="1F2933"/>
+                          </a:solidFill>
+                          <a:latin typeface="Arial"/>
+                        </a:rPr>
+                        <a:t>Student accounts</a:t>
+                      </a:r>
+                    </a:p>
+                  </a:txBody>
+                  <a:tcPr marT="36576" marB="36576">
+                    <a:solidFill>
+                      <a:srgbClr val="FFFFFF"/>
+                    </a:solidFill>
+                  </a:tcPr>
+                </a:tc>
+                <a:tc>
+                  <a:txBody>
+                    <a:bodyPr/>
+                    <a:lstStyle/>
+                    <a:p>
+                      <a:r>
+                        <a:rPr sz="1200" b="0">
+                          <a:solidFill>
+                            <a:srgbClr val="1F2933"/>
+                          </a:solidFill>
+                          <a:latin typeface="Arial"/>
+                        </a:rPr>
+                        <a:t>Partly</a:t>
+                      </a:r>
+                    </a:p>
+                  </a:txBody>
+                  <a:tcPr marT="36576" marB="36576">
+                    <a:solidFill>
+                      <a:srgbClr val="FFFFFF"/>
+                    </a:solidFill>
+                  </a:tcPr>
+                </a:tc>
+                <a:tc>
+                  <a:txBody>
+                    <a:bodyPr/>
+                    <a:lstStyle/>
+                    <a:p>
+                      <a:r>
+                        <a:rPr sz="1200" b="0">
+                          <a:solidFill>
+                            <a:srgbClr val="1F2933"/>
+                          </a:solidFill>
+                          <a:latin typeface="Arial"/>
+                        </a:rPr>
+                        <a:t>Sign-up and sign-in with hashed passwords; no sessions or roles yet</a:t>
+                      </a:r>
+                    </a:p>
+                  </a:txBody>
+                  <a:tcPr marT="36576" marB="36576">
+                    <a:solidFill>
+                      <a:srgbClr val="FFFFFF"/>
+                    </a:solidFill>
+                  </a:tcPr>
+                </a:tc>
+              </a:tr>
+              <a:tr h="457200">
+                <a:tc>
+                  <a:txBody>
+                    <a:bodyPr/>
+                    <a:lstStyle/>
+                    <a:p>
+                      <a:r>
+                        <a:rPr sz="1200" b="0">
+                          <a:solidFill>
+                            <a:srgbClr val="1F2933"/>
+                          </a:solidFill>
+                          <a:latin typeface="Arial"/>
+                        </a:rPr>
+                        <a:t>Caching of frequent reads (Redis)</a:t>
+                      </a:r>
+                    </a:p>
+                  </a:txBody>
+                  <a:tcPr marT="36576" marB="36576">
+                    <a:solidFill>
+                      <a:srgbClr val="FFFFFF"/>
+                    </a:solidFill>
+                  </a:tcPr>
+                </a:tc>
+                <a:tc>
+                  <a:txBody>
+                    <a:bodyPr/>
+                    <a:lstStyle/>
+                    <a:p>
+                      <a:r>
+                        <a:rPr sz="1200" b="0">
+                          <a:solidFill>
+                            <a:srgbClr val="1F2933"/>
+                          </a:solidFill>
+                          <a:latin typeface="Arial"/>
+                        </a:rPr>
+                        <a:t>Not built</a:t>
+                      </a:r>
+                    </a:p>
+                  </a:txBody>
+                  <a:tcPr marT="36576" marB="36576">
+                    <a:solidFill>
+                      <a:srgbClr val="FFFFFF"/>
+                    </a:solidFill>
+                  </a:tcPr>
+                </a:tc>
+                <a:tc>
+                  <a:txBody>
+                    <a:bodyPr/>
+                    <a:lstStyle/>
+                    <a:p>
+                      <a:r>
+                        <a:rPr sz="1200" b="0">
+                          <a:solidFill>
+                            <a:srgbClr val="1F2933"/>
+                          </a:solidFill>
+                          <a:latin typeface="Arial"/>
+                        </a:rPr>
+                        <a:t>Indexes added instead; not needed at this data size</a:t>
+                      </a:r>
+                    </a:p>
+                  </a:txBody>
+                  <a:tcPr marT="36576" marB="36576">
+                    <a:solidFill>
+                      <a:srgbClr val="FFFFFF"/>
+                    </a:solidFill>
+                  </a:tcPr>
+                </a:tc>
+              </a:tr>
+              <a:tr h="457200">
+                <a:tc>
+                  <a:txBody>
+                    <a:bodyPr/>
+                    <a:lstStyle/>
+                    <a:p>
+                      <a:r>
+                        <a:rPr sz="1200" b="0">
+                          <a:solidFill>
+                            <a:srgbClr val="1F2933"/>
+                          </a:solidFill>
+                          <a:latin typeface="Arial"/>
+                        </a:rPr>
+                        <a:t>Database connectivity</a:t>
+                      </a:r>
+                    </a:p>
+                  </a:txBody>
+                  <a:tcPr marT="36576" marB="36576">
+                    <a:solidFill>
+                      <a:srgbClr val="FFFFFF"/>
+                    </a:solidFill>
+                  </a:tcPr>
+                </a:tc>
+                <a:tc>
+                  <a:txBody>
+                    <a:bodyPr/>
+                    <a:lstStyle/>
+                    <a:p>
+                      <a:r>
+                        <a:rPr sz="1200" b="0">
+                          <a:solidFill>
+                            <a:srgbClr val="1F2933"/>
+                          </a:solidFill>
+                          <a:latin typeface="Arial"/>
+                        </a:rPr>
+                        <a:t>Completed</a:t>
+                      </a:r>
+                    </a:p>
+                  </a:txBody>
+                  <a:tcPr marT="36576" marB="36576">
+                    <a:solidFill>
+                      <a:srgbClr val="FFFFFF"/>
+                    </a:solidFill>
+                  </a:tcPr>
+                </a:tc>
+                <a:tc>
+                  <a:txBody>
+                    <a:bodyPr/>
+                    <a:lstStyle/>
+                    <a:p>
+                      <a:r>
+                        <a:rPr sz="1200" b="0">
+                          <a:solidFill>
+                            <a:srgbClr val="1F2933"/>
+                          </a:solidFill>
+                          <a:latin typeface="Arial"/>
+                        </a:rPr>
+                        <a:t>node-postgres for the web app; JDBC and ODBC console clients</a:t>
+                      </a:r>
+                    </a:p>
+                  </a:txBody>
+                  <a:tcPr marT="36576" marB="36576">
+                    <a:solidFill>
+                      <a:srgbClr val="FFFFFF"/>
+                    </a:solidFill>
+                  </a:tcPr>
+                </a:tc>
+              </a:tr>
+            </a:tbl>
+          </a:graphicData>
+        </a:graphic>
+      </p:graphicFrame>
     </p:spTree>
   </p:cSld>
   <p:clrMapOvr>
@@ -4760,7 +4457,7 @@
                 </a:solidFill>
                 <a:latin typeface="Arial"/>
               </a:rPr>
-              <a:t>Conclusion</a:t>
+              <a:t>Demonstration</a:t>
             </a:r>
           </a:p>
         </p:txBody>
@@ -4815,7 +4512,7 @@
                 </a:solidFill>
                 <a:latin typeface="Georgia"/>
               </a:rPr>
-              <a:t>Conclusion and Future Enhancements</a:t>
+              <a:t>Live Demo Flow</a:t>
             </a:r>
           </a:p>
         </p:txBody>
@@ -4871,6 +4568,895 @@
                 <a:latin typeface="Arial"/>
               </a:rPr>
               <a:t>Adaptive Learning Platform · Phase 3 · 14</a:t>
+            </a:r>
+          </a:p>
+        </p:txBody>
+      </p:sp>
+      <p:sp>
+        <p:nvSpPr>
+          <p:cNvPr id="5" name="Rounded Rectangle 4"/>
+          <p:cNvSpPr/>
+          <p:nvPr/>
+        </p:nvSpPr>
+        <p:spPr>
+          <a:xfrm>
+            <a:off x="587044" y="1371600"/>
+            <a:ext cx="1874519" cy="777240"/>
+          </a:xfrm>
+          <a:prstGeom prst="roundRect">
+            <a:avLst/>
+          </a:prstGeom>
+          <a:solidFill>
+            <a:srgbClr val="14284B"/>
+          </a:solidFill>
+          <a:ln>
+            <a:noFill/>
+          </a:ln>
+          <a:effectLst/>
+        </p:spPr>
+        <p:style>
+          <a:lnRef idx="1">
+            <a:schemeClr val="accent1"/>
+          </a:lnRef>
+          <a:fillRef idx="3">
+            <a:schemeClr val="accent1"/>
+          </a:fillRef>
+          <a:effectRef idx="2">
+            <a:schemeClr val="accent1"/>
+          </a:effectRef>
+          <a:fontRef idx="minor">
+            <a:schemeClr val="lt1"/>
+          </a:fontRef>
+        </p:style>
+        <p:txBody>
+          <a:bodyPr rtlCol="0" anchor="ctr" wrap="square" lIns="109728" rIns="109728"/>
+          <a:lstStyle/>
+          <a:p>
+            <a:pPr algn="ctr">
+              <a:spcAft>
+                <a:spcPts val="0"/>
+              </a:spcAft>
+            </a:pPr>
+            <a:r>
+              <a:rPr sz="1100" b="1">
+                <a:solidFill>
+                  <a:srgbClr val="C9962B"/>
+                </a:solidFill>
+                <a:latin typeface="Arial"/>
+              </a:rPr>
+              <a:t>STEP 1</a:t>
+            </a:r>
+          </a:p>
+          <a:p>
+            <a:pPr algn="ctr">
+              <a:spcAft>
+                <a:spcPts val="400"/>
+              </a:spcAft>
+            </a:pPr>
+            <a:r>
+              <a:rPr sz="1300" b="1">
+                <a:solidFill>
+                  <a:srgbClr val="FFFFFF"/>
+                </a:solidFill>
+                <a:latin typeface="Arial"/>
+              </a:rPr>
+              <a:t>Sign up</a:t>
+            </a:r>
+          </a:p>
+        </p:txBody>
+      </p:sp>
+      <p:sp>
+        <p:nvSpPr>
+          <p:cNvPr id="6" name="Rectangle 5"/>
+          <p:cNvSpPr/>
+          <p:nvPr/>
+        </p:nvSpPr>
+        <p:spPr>
+          <a:xfrm>
+            <a:off x="2461564" y="1572768"/>
+            <a:ext cx="411480" cy="365760"/>
+          </a:xfrm>
+          <a:prstGeom prst="rect">
+            <a:avLst/>
+          </a:prstGeom>
+          <a:noFill/>
+          <a:ln>
+            <a:noFill/>
+          </a:ln>
+          <a:effectLst/>
+        </p:spPr>
+        <p:style>
+          <a:lnRef idx="1">
+            <a:schemeClr val="accent1"/>
+          </a:lnRef>
+          <a:fillRef idx="3">
+            <a:schemeClr val="accent1"/>
+          </a:fillRef>
+          <a:effectRef idx="2">
+            <a:schemeClr val="accent1"/>
+          </a:effectRef>
+          <a:fontRef idx="minor">
+            <a:schemeClr val="lt1"/>
+          </a:fontRef>
+        </p:style>
+        <p:txBody>
+          <a:bodyPr rtlCol="0" anchor="t" wrap="square" lIns="0" rIns="0"/>
+          <a:lstStyle/>
+          <a:p>
+            <a:pPr algn="ctr">
+              <a:spcAft>
+                <a:spcPts val="400"/>
+              </a:spcAft>
+            </a:pPr>
+            <a:r>
+              <a:rPr sz="1800" b="0">
+                <a:solidFill>
+                  <a:srgbClr val="C9962B"/>
+                </a:solidFill>
+                <a:latin typeface="Arial"/>
+              </a:rPr>
+              <a:t>→</a:t>
+            </a:r>
+          </a:p>
+        </p:txBody>
+      </p:sp>
+      <p:sp>
+        <p:nvSpPr>
+          <p:cNvPr id="7" name="Rounded Rectangle 6"/>
+          <p:cNvSpPr/>
+          <p:nvPr/>
+        </p:nvSpPr>
+        <p:spPr>
+          <a:xfrm>
+            <a:off x="2873044" y="1371600"/>
+            <a:ext cx="1874519" cy="777240"/>
+          </a:xfrm>
+          <a:prstGeom prst="roundRect">
+            <a:avLst/>
+          </a:prstGeom>
+          <a:solidFill>
+            <a:srgbClr val="14284B"/>
+          </a:solidFill>
+          <a:ln>
+            <a:noFill/>
+          </a:ln>
+          <a:effectLst/>
+        </p:spPr>
+        <p:style>
+          <a:lnRef idx="1">
+            <a:schemeClr val="accent1"/>
+          </a:lnRef>
+          <a:fillRef idx="3">
+            <a:schemeClr val="accent1"/>
+          </a:fillRef>
+          <a:effectRef idx="2">
+            <a:schemeClr val="accent1"/>
+          </a:effectRef>
+          <a:fontRef idx="minor">
+            <a:schemeClr val="lt1"/>
+          </a:fontRef>
+        </p:style>
+        <p:txBody>
+          <a:bodyPr rtlCol="0" anchor="ctr" wrap="square" lIns="109728" rIns="109728"/>
+          <a:lstStyle/>
+          <a:p>
+            <a:pPr algn="ctr">
+              <a:spcAft>
+                <a:spcPts val="0"/>
+              </a:spcAft>
+            </a:pPr>
+            <a:r>
+              <a:rPr sz="1100" b="1">
+                <a:solidFill>
+                  <a:srgbClr val="C9962B"/>
+                </a:solidFill>
+                <a:latin typeface="Arial"/>
+              </a:rPr>
+              <a:t>STEP 2</a:t>
+            </a:r>
+          </a:p>
+          <a:p>
+            <a:pPr algn="ctr">
+              <a:spcAft>
+                <a:spcPts val="400"/>
+              </a:spcAft>
+            </a:pPr>
+            <a:r>
+              <a:rPr sz="1300" b="1">
+                <a:solidFill>
+                  <a:srgbClr val="FFFFFF"/>
+                </a:solidFill>
+                <a:latin typeface="Arial"/>
+              </a:rPr>
+              <a:t>Take a quiz</a:t>
+            </a:r>
+          </a:p>
+        </p:txBody>
+      </p:sp>
+      <p:sp>
+        <p:nvSpPr>
+          <p:cNvPr id="8" name="Rectangle 7"/>
+          <p:cNvSpPr/>
+          <p:nvPr/>
+        </p:nvSpPr>
+        <p:spPr>
+          <a:xfrm>
+            <a:off x="4747564" y="1572768"/>
+            <a:ext cx="411480" cy="365760"/>
+          </a:xfrm>
+          <a:prstGeom prst="rect">
+            <a:avLst/>
+          </a:prstGeom>
+          <a:noFill/>
+          <a:ln>
+            <a:noFill/>
+          </a:ln>
+          <a:effectLst/>
+        </p:spPr>
+        <p:style>
+          <a:lnRef idx="1">
+            <a:schemeClr val="accent1"/>
+          </a:lnRef>
+          <a:fillRef idx="3">
+            <a:schemeClr val="accent1"/>
+          </a:fillRef>
+          <a:effectRef idx="2">
+            <a:schemeClr val="accent1"/>
+          </a:effectRef>
+          <a:fontRef idx="minor">
+            <a:schemeClr val="lt1"/>
+          </a:fontRef>
+        </p:style>
+        <p:txBody>
+          <a:bodyPr rtlCol="0" anchor="t" wrap="square" lIns="0" rIns="0"/>
+          <a:lstStyle/>
+          <a:p>
+            <a:pPr algn="ctr">
+              <a:spcAft>
+                <a:spcPts val="400"/>
+              </a:spcAft>
+            </a:pPr>
+            <a:r>
+              <a:rPr sz="1800" b="0">
+                <a:solidFill>
+                  <a:srgbClr val="C9962B"/>
+                </a:solidFill>
+                <a:latin typeface="Arial"/>
+              </a:rPr>
+              <a:t>→</a:t>
+            </a:r>
+          </a:p>
+        </p:txBody>
+      </p:sp>
+      <p:sp>
+        <p:nvSpPr>
+          <p:cNvPr id="9" name="Rounded Rectangle 8"/>
+          <p:cNvSpPr/>
+          <p:nvPr/>
+        </p:nvSpPr>
+        <p:spPr>
+          <a:xfrm>
+            <a:off x="5159044" y="1371600"/>
+            <a:ext cx="1874519" cy="777240"/>
+          </a:xfrm>
+          <a:prstGeom prst="roundRect">
+            <a:avLst/>
+          </a:prstGeom>
+          <a:solidFill>
+            <a:srgbClr val="14284B"/>
+          </a:solidFill>
+          <a:ln>
+            <a:noFill/>
+          </a:ln>
+          <a:effectLst/>
+        </p:spPr>
+        <p:style>
+          <a:lnRef idx="1">
+            <a:schemeClr val="accent1"/>
+          </a:lnRef>
+          <a:fillRef idx="3">
+            <a:schemeClr val="accent1"/>
+          </a:fillRef>
+          <a:effectRef idx="2">
+            <a:schemeClr val="accent1"/>
+          </a:effectRef>
+          <a:fontRef idx="minor">
+            <a:schemeClr val="lt1"/>
+          </a:fontRef>
+        </p:style>
+        <p:txBody>
+          <a:bodyPr rtlCol="0" anchor="ctr" wrap="square" lIns="109728" rIns="109728"/>
+          <a:lstStyle/>
+          <a:p>
+            <a:pPr algn="ctr">
+              <a:spcAft>
+                <a:spcPts val="0"/>
+              </a:spcAft>
+            </a:pPr>
+            <a:r>
+              <a:rPr sz="1100" b="1">
+                <a:solidFill>
+                  <a:srgbClr val="C9962B"/>
+                </a:solidFill>
+                <a:latin typeface="Arial"/>
+              </a:rPr>
+              <a:t>STEP 3</a:t>
+            </a:r>
+          </a:p>
+          <a:p>
+            <a:pPr algn="ctr">
+              <a:spcAft>
+                <a:spcPts val="400"/>
+              </a:spcAft>
+            </a:pPr>
+            <a:r>
+              <a:rPr sz="1300" b="1">
+                <a:solidFill>
+                  <a:srgbClr val="FFFFFF"/>
+                </a:solidFill>
+                <a:latin typeface="Arial"/>
+              </a:rPr>
+              <a:t>See proficiency</a:t>
+            </a:r>
+          </a:p>
+        </p:txBody>
+      </p:sp>
+      <p:sp>
+        <p:nvSpPr>
+          <p:cNvPr id="10" name="Rectangle 9"/>
+          <p:cNvSpPr/>
+          <p:nvPr/>
+        </p:nvSpPr>
+        <p:spPr>
+          <a:xfrm>
+            <a:off x="7033564" y="1572768"/>
+            <a:ext cx="411480" cy="365760"/>
+          </a:xfrm>
+          <a:prstGeom prst="rect">
+            <a:avLst/>
+          </a:prstGeom>
+          <a:noFill/>
+          <a:ln>
+            <a:noFill/>
+          </a:ln>
+          <a:effectLst/>
+        </p:spPr>
+        <p:style>
+          <a:lnRef idx="1">
+            <a:schemeClr val="accent1"/>
+          </a:lnRef>
+          <a:fillRef idx="3">
+            <a:schemeClr val="accent1"/>
+          </a:fillRef>
+          <a:effectRef idx="2">
+            <a:schemeClr val="accent1"/>
+          </a:effectRef>
+          <a:fontRef idx="minor">
+            <a:schemeClr val="lt1"/>
+          </a:fontRef>
+        </p:style>
+        <p:txBody>
+          <a:bodyPr rtlCol="0" anchor="t" wrap="square" lIns="0" rIns="0"/>
+          <a:lstStyle/>
+          <a:p>
+            <a:pPr algn="ctr">
+              <a:spcAft>
+                <a:spcPts val="400"/>
+              </a:spcAft>
+            </a:pPr>
+            <a:r>
+              <a:rPr sz="1800" b="0">
+                <a:solidFill>
+                  <a:srgbClr val="C9962B"/>
+                </a:solidFill>
+                <a:latin typeface="Arial"/>
+              </a:rPr>
+              <a:t>→</a:t>
+            </a:r>
+          </a:p>
+        </p:txBody>
+      </p:sp>
+      <p:sp>
+        <p:nvSpPr>
+          <p:cNvPr id="11" name="Rounded Rectangle 10"/>
+          <p:cNvSpPr/>
+          <p:nvPr/>
+        </p:nvSpPr>
+        <p:spPr>
+          <a:xfrm>
+            <a:off x="7445044" y="1371600"/>
+            <a:ext cx="1874519" cy="777240"/>
+          </a:xfrm>
+          <a:prstGeom prst="roundRect">
+            <a:avLst/>
+          </a:prstGeom>
+          <a:solidFill>
+            <a:srgbClr val="14284B"/>
+          </a:solidFill>
+          <a:ln>
+            <a:noFill/>
+          </a:ln>
+          <a:effectLst/>
+        </p:spPr>
+        <p:style>
+          <a:lnRef idx="1">
+            <a:schemeClr val="accent1"/>
+          </a:lnRef>
+          <a:fillRef idx="3">
+            <a:schemeClr val="accent1"/>
+          </a:fillRef>
+          <a:effectRef idx="2">
+            <a:schemeClr val="accent1"/>
+          </a:effectRef>
+          <a:fontRef idx="minor">
+            <a:schemeClr val="lt1"/>
+          </a:fontRef>
+        </p:style>
+        <p:txBody>
+          <a:bodyPr rtlCol="0" anchor="ctr" wrap="square" lIns="109728" rIns="109728"/>
+          <a:lstStyle/>
+          <a:p>
+            <a:pPr algn="ctr">
+              <a:spcAft>
+                <a:spcPts val="0"/>
+              </a:spcAft>
+            </a:pPr>
+            <a:r>
+              <a:rPr sz="1100" b="1">
+                <a:solidFill>
+                  <a:srgbClr val="C9962B"/>
+                </a:solidFill>
+                <a:latin typeface="Arial"/>
+              </a:rPr>
+              <a:t>STEP 4</a:t>
+            </a:r>
+          </a:p>
+          <a:p>
+            <a:pPr algn="ctr">
+              <a:spcAft>
+                <a:spcPts val="400"/>
+              </a:spcAft>
+            </a:pPr>
+            <a:r>
+              <a:rPr sz="1300" b="1">
+                <a:solidFill>
+                  <a:srgbClr val="FFFFFF"/>
+                </a:solidFill>
+                <a:latin typeface="Arial"/>
+              </a:rPr>
+              <a:t>Refresh recommendations</a:t>
+            </a:r>
+          </a:p>
+        </p:txBody>
+      </p:sp>
+      <p:sp>
+        <p:nvSpPr>
+          <p:cNvPr id="12" name="Rectangle 11"/>
+          <p:cNvSpPr/>
+          <p:nvPr/>
+        </p:nvSpPr>
+        <p:spPr>
+          <a:xfrm>
+            <a:off x="9319564" y="1572768"/>
+            <a:ext cx="411480" cy="365760"/>
+          </a:xfrm>
+          <a:prstGeom prst="rect">
+            <a:avLst/>
+          </a:prstGeom>
+          <a:noFill/>
+          <a:ln>
+            <a:noFill/>
+          </a:ln>
+          <a:effectLst/>
+        </p:spPr>
+        <p:style>
+          <a:lnRef idx="1">
+            <a:schemeClr val="accent1"/>
+          </a:lnRef>
+          <a:fillRef idx="3">
+            <a:schemeClr val="accent1"/>
+          </a:fillRef>
+          <a:effectRef idx="2">
+            <a:schemeClr val="accent1"/>
+          </a:effectRef>
+          <a:fontRef idx="minor">
+            <a:schemeClr val="lt1"/>
+          </a:fontRef>
+        </p:style>
+        <p:txBody>
+          <a:bodyPr rtlCol="0" anchor="t" wrap="square" lIns="0" rIns="0"/>
+          <a:lstStyle/>
+          <a:p>
+            <a:pPr algn="ctr">
+              <a:spcAft>
+                <a:spcPts val="400"/>
+              </a:spcAft>
+            </a:pPr>
+            <a:r>
+              <a:rPr sz="1800" b="0">
+                <a:solidFill>
+                  <a:srgbClr val="C9962B"/>
+                </a:solidFill>
+                <a:latin typeface="Arial"/>
+              </a:rPr>
+              <a:t>→</a:t>
+            </a:r>
+          </a:p>
+        </p:txBody>
+      </p:sp>
+      <p:sp>
+        <p:nvSpPr>
+          <p:cNvPr id="13" name="Rounded Rectangle 12"/>
+          <p:cNvSpPr/>
+          <p:nvPr/>
+        </p:nvSpPr>
+        <p:spPr>
+          <a:xfrm>
+            <a:off x="9731044" y="1371600"/>
+            <a:ext cx="1874519" cy="777240"/>
+          </a:xfrm>
+          <a:prstGeom prst="roundRect">
+            <a:avLst/>
+          </a:prstGeom>
+          <a:solidFill>
+            <a:srgbClr val="14284B"/>
+          </a:solidFill>
+          <a:ln>
+            <a:noFill/>
+          </a:ln>
+          <a:effectLst/>
+        </p:spPr>
+        <p:style>
+          <a:lnRef idx="1">
+            <a:schemeClr val="accent1"/>
+          </a:lnRef>
+          <a:fillRef idx="3">
+            <a:schemeClr val="accent1"/>
+          </a:fillRef>
+          <a:effectRef idx="2">
+            <a:schemeClr val="accent1"/>
+          </a:effectRef>
+          <a:fontRef idx="minor">
+            <a:schemeClr val="lt1"/>
+          </a:fontRef>
+        </p:style>
+        <p:txBody>
+          <a:bodyPr rtlCol="0" anchor="ctr" wrap="square" lIns="109728" rIns="109728"/>
+          <a:lstStyle/>
+          <a:p>
+            <a:pPr algn="ctr">
+              <a:spcAft>
+                <a:spcPts val="0"/>
+              </a:spcAft>
+            </a:pPr>
+            <a:r>
+              <a:rPr sz="1100" b="1">
+                <a:solidFill>
+                  <a:srgbClr val="C9962B"/>
+                </a:solidFill>
+                <a:latin typeface="Arial"/>
+              </a:rPr>
+              <a:t>STEP 5</a:t>
+            </a:r>
+          </a:p>
+          <a:p>
+            <a:pPr algn="ctr">
+              <a:spcAft>
+                <a:spcPts val="400"/>
+              </a:spcAft>
+            </a:pPr>
+            <a:r>
+              <a:rPr sz="1300" b="1">
+                <a:solidFill>
+                  <a:srgbClr val="FFFFFF"/>
+                </a:solidFill>
+                <a:latin typeface="Arial"/>
+              </a:rPr>
+              <a:t>Leaderboard</a:t>
+            </a:r>
+          </a:p>
+        </p:txBody>
+      </p:sp>
+      <p:sp>
+        <p:nvSpPr>
+          <p:cNvPr id="14" name="Rectangle 13"/>
+          <p:cNvSpPr/>
+          <p:nvPr/>
+        </p:nvSpPr>
+        <p:spPr>
+          <a:xfrm>
+            <a:off x="609904" y="2651760"/>
+            <a:ext cx="10972800" cy="3291840"/>
+          </a:xfrm>
+          <a:prstGeom prst="rect">
+            <a:avLst/>
+          </a:prstGeom>
+          <a:solidFill>
+            <a:srgbClr val="F3F4F6"/>
+          </a:solidFill>
+          <a:ln>
+            <a:noFill/>
+          </a:ln>
+          <a:effectLst/>
+        </p:spPr>
+        <p:style>
+          <a:lnRef idx="1">
+            <a:schemeClr val="accent1"/>
+          </a:lnRef>
+          <a:fillRef idx="3">
+            <a:schemeClr val="accent1"/>
+          </a:fillRef>
+          <a:effectRef idx="2">
+            <a:schemeClr val="accent1"/>
+          </a:effectRef>
+          <a:fontRef idx="minor">
+            <a:schemeClr val="lt1"/>
+          </a:fontRef>
+        </p:style>
+        <p:txBody>
+          <a:bodyPr rtlCol="0" anchor="t" wrap="square" lIns="201168" rIns="201168"/>
+          <a:lstStyle/>
+          <a:p>
+            <a:pPr algn="l">
+              <a:spcAft>
+                <a:spcPts val="400"/>
+              </a:spcAft>
+            </a:pPr>
+            <a:r>
+              <a:rPr sz="1600" b="1">
+                <a:solidFill>
+                  <a:srgbClr val="14284B"/>
+                </a:solidFill>
+                <a:latin typeface="Arial"/>
+              </a:rPr>
+              <a:t>Then show the database side</a:t>
+            </a:r>
+          </a:p>
+          <a:p>
+            <a:pPr algn="l">
+              <a:spcAft>
+                <a:spcPts val="400"/>
+              </a:spcAft>
+            </a:pPr>
+            <a:r>
+              <a:rPr sz="1400" b="0">
+                <a:solidFill>
+                  <a:srgbClr val="1F2933"/>
+                </a:solidFill>
+                <a:latin typeface="Arial"/>
+              </a:rPr>
+              <a:t>psql: SELECT the new attempt and the updated topic_proficiency row.</a:t>
+            </a:r>
+          </a:p>
+          <a:p>
+            <a:pPr algn="l">
+              <a:spcAft>
+                <a:spcPts val="400"/>
+              </a:spcAft>
+            </a:pPr>
+            <a:r>
+              <a:rPr sz="1400" b="0">
+                <a:solidFill>
+                  <a:srgbClr val="1F2933"/>
+                </a:solidFill>
+                <a:latin typeface="Arial"/>
+              </a:rPr>
+              <a:t>Topics: add, edit, delete, then try to delete Arrays to show the trigger message.</a:t>
+            </a:r>
+          </a:p>
+          <a:p>
+            <a:pPr algn="l">
+              <a:spcAft>
+                <a:spcPts val="400"/>
+              </a:spcAft>
+            </a:pPr>
+            <a:r>
+              <a:rPr sz="1400" b="0">
+                <a:solidFill>
+                  <a:srgbClr val="1F2933"/>
+                </a:solidFill>
+                <a:latin typeface="Arial"/>
+              </a:rPr>
+              <a:t>Java and ODBC: run JdbcDemo --demo and OdbcDemo.ps1 -Demo; the same functions are called.</a:t>
+            </a:r>
+          </a:p>
+          <a:p>
+            <a:pPr algn="l">
+              <a:spcAft>
+                <a:spcPts val="400"/>
+              </a:spcAft>
+            </a:pPr>
+            <a:r>
+              <a:rPr sz="1400" b="0">
+                <a:solidFill>
+                  <a:srgbClr val="1F2933"/>
+                </a:solidFill>
+                <a:latin typeface="Arial"/>
+              </a:rPr>
+              <a:t>Terminal: npm test, 31 of 31 passing.</a:t>
+            </a:r>
+          </a:p>
+        </p:txBody>
+      </p:sp>
+    </p:spTree>
+  </p:cSld>
+  <p:clrMapOvr>
+    <a:masterClrMapping/>
+  </p:clrMapOvr>
+</p:sld>
+</file>
+
+<file path=ppt/slides/slide15.xml><?xml version="1.0" encoding="utf-8"?>
+<p:sld xmlns:a="http://schemas.openxmlformats.org/drawingml/2006/main" xmlns:p="http://schemas.openxmlformats.org/presentationml/2006/main" xmlns:r="http://schemas.openxmlformats.org/officeDocument/2006/relationships">
+  <p:cSld>
+    <p:spTree>
+      <p:nvGrpSpPr>
+        <p:cNvPr id="1" name=""/>
+        <p:cNvGrpSpPr/>
+        <p:nvPr/>
+      </p:nvGrpSpPr>
+      <p:grpSpPr/>
+      <p:sp>
+        <p:nvSpPr>
+          <p:cNvPr id="2" name="Rectangle 1"/>
+          <p:cNvSpPr/>
+          <p:nvPr/>
+        </p:nvSpPr>
+        <p:spPr>
+          <a:xfrm>
+            <a:off x="609904" y="384048"/>
+            <a:ext cx="10972800" cy="274320"/>
+          </a:xfrm>
+          <a:prstGeom prst="rect">
+            <a:avLst/>
+          </a:prstGeom>
+          <a:noFill/>
+          <a:ln>
+            <a:noFill/>
+          </a:ln>
+          <a:effectLst/>
+        </p:spPr>
+        <p:style>
+          <a:lnRef idx="1">
+            <a:schemeClr val="accent1"/>
+          </a:lnRef>
+          <a:fillRef idx="3">
+            <a:schemeClr val="accent1"/>
+          </a:fillRef>
+          <a:effectRef idx="2">
+            <a:schemeClr val="accent1"/>
+          </a:effectRef>
+          <a:fontRef idx="minor">
+            <a:schemeClr val="lt1"/>
+          </a:fontRef>
+        </p:style>
+        <p:txBody>
+          <a:bodyPr rtlCol="0" anchor="t" wrap="square" lIns="0" rIns="0"/>
+          <a:lstStyle/>
+          <a:p>
+            <a:pPr algn="l">
+              <a:spcAft>
+                <a:spcPts val="400"/>
+              </a:spcAft>
+            </a:pPr>
+            <a:r>
+              <a:rPr sz="1200" b="1">
+                <a:solidFill>
+                  <a:srgbClr val="C9962B"/>
+                </a:solidFill>
+                <a:latin typeface="Arial"/>
+              </a:rPr>
+              <a:t>Conclusion</a:t>
+            </a:r>
+          </a:p>
+        </p:txBody>
+      </p:sp>
+      <p:sp>
+        <p:nvSpPr>
+          <p:cNvPr id="3" name="Rectangle 2"/>
+          <p:cNvSpPr/>
+          <p:nvPr/>
+        </p:nvSpPr>
+        <p:spPr>
+          <a:xfrm>
+            <a:off x="609904" y="713232"/>
+            <a:ext cx="10972800" cy="457200"/>
+          </a:xfrm>
+          <a:prstGeom prst="rect">
+            <a:avLst/>
+          </a:prstGeom>
+          <a:noFill/>
+          <a:ln>
+            <a:noFill/>
+          </a:ln>
+          <a:effectLst/>
+        </p:spPr>
+        <p:style>
+          <a:lnRef idx="1">
+            <a:schemeClr val="accent1"/>
+          </a:lnRef>
+          <a:fillRef idx="3">
+            <a:schemeClr val="accent1"/>
+          </a:fillRef>
+          <a:effectRef idx="2">
+            <a:schemeClr val="accent1"/>
+          </a:effectRef>
+          <a:fontRef idx="minor">
+            <a:schemeClr val="lt1"/>
+          </a:fontRef>
+        </p:style>
+        <p:txBody>
+          <a:bodyPr rtlCol="0" anchor="t" wrap="square" lIns="0" rIns="0"/>
+          <a:lstStyle/>
+          <a:p>
+            <a:pPr algn="l">
+              <a:spcAft>
+                <a:spcPts val="400"/>
+              </a:spcAft>
+            </a:pPr>
+            <a:r>
+              <a:rPr sz="2700" b="1">
+                <a:solidFill>
+                  <a:srgbClr val="14284B"/>
+                </a:solidFill>
+                <a:latin typeface="Georgia"/>
+              </a:rPr>
+              <a:t>Conclusion and Future Enhancements</a:t>
+            </a:r>
+          </a:p>
+        </p:txBody>
+      </p:sp>
+      <p:sp>
+        <p:nvSpPr>
+          <p:cNvPr id="4" name="Rectangle 3"/>
+          <p:cNvSpPr/>
+          <p:nvPr/>
+        </p:nvSpPr>
+        <p:spPr>
+          <a:xfrm>
+            <a:off x="609904" y="6364224"/>
+            <a:ext cx="10972800" cy="274320"/>
+          </a:xfrm>
+          <a:prstGeom prst="rect">
+            <a:avLst/>
+          </a:prstGeom>
+          <a:noFill/>
+          <a:ln>
+            <a:noFill/>
+          </a:ln>
+          <a:effectLst/>
+        </p:spPr>
+        <p:style>
+          <a:lnRef idx="1">
+            <a:schemeClr val="accent1"/>
+          </a:lnRef>
+          <a:fillRef idx="3">
+            <a:schemeClr val="accent1"/>
+          </a:fillRef>
+          <a:effectRef idx="2">
+            <a:schemeClr val="accent1"/>
+          </a:effectRef>
+          <a:fontRef idx="minor">
+            <a:schemeClr val="lt1"/>
+          </a:fontRef>
+        </p:style>
+        <p:txBody>
+          <a:bodyPr rtlCol="0" anchor="t" wrap="square" lIns="0" rIns="0"/>
+          <a:lstStyle/>
+          <a:p>
+            <a:pPr algn="l">
+              <a:spcAft>
+                <a:spcPts val="400"/>
+              </a:spcAft>
+            </a:pPr>
+            <a:r>
+              <a:rPr sz="1200" b="0">
+                <a:solidFill>
+                  <a:srgbClr val="6A7179"/>
+                </a:solidFill>
+                <a:latin typeface="Arial"/>
+              </a:rPr>
+              <a:t>Adaptive Learning Platform · Phase 3 · 15</a:t>
             </a:r>
           </a:p>
         </p:txBody>
@@ -5024,7 +5610,7 @@
                           </a:solidFill>
                           <a:latin typeface="Arial"/>
                         </a:rPr>
-                        <a:t>Web app through node-postgres; Java client through JDBC; all CRUD operations</a:t>
+                        <a:t>Web app through node-postgres; Java client through JDBC; PowerShell client through ODBC; all CRUD operations</a:t>
                       </a:r>
                     </a:p>
                   </a:txBody>
@@ -5816,7 +6402,7 @@
                 </a:solidFill>
                 <a:latin typeface="Arial"/>
               </a:rPr>
-              <a:t>A Java JDBC client that runs the same retrieval, DML and business-logic functions.</a:t>
+              <a:t>Java JDBC and PowerShell ODBC clients that run the same retrieval, DML and business-logic functions.</a:t>
             </a:r>
           </a:p>
           <a:p>
@@ -6160,7 +6746,7 @@
                 </a:solidFill>
                 <a:latin typeface="Arial"/>
               </a:rPr>
-              <a:t>A Java client connects straight to PostgreSQL with the JDBC driver.</a:t>
+              <a:t>A Java client (JDBC) and a PowerShell client (ODBC) connect straight to PostgreSQL.</a:t>
             </a:r>
           </a:p>
           <a:p>

</xml_diff>

<commit_message>
docs: rebuild the Phase 3 presentation with the SkillSync title
</commit_message>
<xml_diff>
--- a/docs/Phase 3 - Integration and Delivery.pptx
+++ b/docs/Phase 3 - Integration and Delivery.pptx
@@ -973,7 +973,7 @@
               <a:buNone/>
             </a:pPr>
             <a:r>
-              <a:rPr lang="en-US" sz="4600" b="1" i="0" dirty="0">
+              <a:rPr lang="en-US" sz="2300" b="1" i="0" dirty="0">
                 <a:solidFill>
                   <a:srgbClr val="0F2A5C"/>
                 </a:solidFill>
@@ -981,7 +981,7 @@
                 <a:ea typeface="Calibri" pitchFamily="34" charset="-122"/>
                 <a:cs typeface="Calibri" pitchFamily="34" charset="-120"/>
               </a:rPr>
-              <a:t>Adaptive Learning Platform</a:t>
+              <a:t>SkillSync: Adaptive Quiz Recommendation &amp; Learning Analytics Platform</a:t>
             </a:r>
             <a:endParaRPr lang="en-US" sz="4600" dirty="0"/>
           </a:p>
@@ -1560,7 +1560,7 @@
                 </a:solidFill>
                 <a:latin typeface="Arial"/>
               </a:rPr>
-              <a:t>Adaptive Learning Platform · Phase 3 · 10</a:t>
+              <a:t>SkillSync · Phase 3 · 10</a:t>
             </a:r>
           </a:p>
         </p:txBody>
@@ -2145,7 +2145,7 @@
                 </a:solidFill>
                 <a:latin typeface="Arial"/>
               </a:rPr>
-              <a:t>Adaptive Learning Platform · Phase 3 · 11</a:t>
+              <a:t>SkillSync · Phase 3 · 11</a:t>
             </a:r>
           </a:p>
         </p:txBody>
@@ -2730,7 +2730,7 @@
                 </a:solidFill>
                 <a:latin typeface="Arial"/>
               </a:rPr>
-              <a:t>Adaptive Learning Platform · Phase 3 · 12</a:t>
+              <a:t>SkillSync · Phase 3 · 12</a:t>
             </a:r>
           </a:p>
         </p:txBody>
@@ -3745,7 +3745,7 @@
                 </a:solidFill>
                 <a:latin typeface="Arial"/>
               </a:rPr>
-              <a:t>Adaptive Learning Platform · Phase 3 · 13</a:t>
+              <a:t>SkillSync · Phase 3 · 13</a:t>
             </a:r>
           </a:p>
         </p:txBody>
@@ -4567,7 +4567,7 @@
                 </a:solidFill>
                 <a:latin typeface="Arial"/>
               </a:rPr>
-              <a:t>Adaptive Learning Platform · Phase 3 · 14</a:t>
+              <a:t>SkillSync · Phase 3 · 14</a:t>
             </a:r>
           </a:p>
         </p:txBody>
@@ -5456,7 +5456,7 @@
                 </a:solidFill>
                 <a:latin typeface="Arial"/>
               </a:rPr>
-              <a:t>Adaptive Learning Platform · Phase 3 · 15</a:t>
+              <a:t>SkillSync · Phase 3 · 15</a:t>
             </a:r>
           </a:p>
         </p:txBody>
@@ -6014,7 +6014,7 @@
                 </a:solidFill>
                 <a:latin typeface="Arial"/>
               </a:rPr>
-              <a:t>Adaptive Learning Platform · Phase 3 · 2</a:t>
+              <a:t>SkillSync · Phase 3 · 2</a:t>
             </a:r>
           </a:p>
         </p:txBody>
@@ -6617,7 +6617,7 @@
                 </a:solidFill>
                 <a:latin typeface="Arial"/>
               </a:rPr>
-              <a:t>Adaptive Learning Platform · Phase 3 · 3</a:t>
+              <a:t>SkillSync · Phase 3 · 3</a:t>
             </a:r>
           </a:p>
         </p:txBody>
@@ -6945,7 +6945,7 @@
                 </a:solidFill>
                 <a:latin typeface="Arial"/>
               </a:rPr>
-              <a:t>Adaptive Learning Platform · Phase 3 · 4</a:t>
+              <a:t>SkillSync · Phase 3 · 4</a:t>
             </a:r>
           </a:p>
         </p:txBody>
@@ -7767,7 +7767,7 @@
                 </a:solidFill>
                 <a:latin typeface="Arial"/>
               </a:rPr>
-              <a:t>Adaptive Learning Platform · Phase 3 · 5</a:t>
+              <a:t>SkillSync · Phase 3 · 5</a:t>
             </a:r>
           </a:p>
         </p:txBody>
@@ -8165,7 +8165,7 @@
                 </a:solidFill>
                 <a:latin typeface="Arial"/>
               </a:rPr>
-              <a:t>Adaptive Learning Platform · Phase 3 · 6</a:t>
+              <a:t>SkillSync · Phase 3 · 6</a:t>
             </a:r>
           </a:p>
         </p:txBody>
@@ -9436,7 +9436,7 @@
                 </a:solidFill>
                 <a:latin typeface="Arial"/>
               </a:rPr>
-              <a:t>Adaptive Learning Platform · Phase 3 · 7</a:t>
+              <a:t>SkillSync · Phase 3 · 7</a:t>
             </a:r>
           </a:p>
         </p:txBody>
@@ -9764,7 +9764,7 @@
                 </a:solidFill>
                 <a:latin typeface="Arial"/>
               </a:rPr>
-              <a:t>Adaptive Learning Platform · Phase 3 · 8</a:t>
+              <a:t>SkillSync · Phase 3 · 8</a:t>
             </a:r>
           </a:p>
         </p:txBody>
@@ -10241,7 +10241,7 @@
                 </a:solidFill>
                 <a:latin typeface="Arial"/>
               </a:rPr>
-              <a:t>Adaptive Learning Platform · Phase 3 · 9</a:t>
+              <a:t>SkillSync · Phase 3 · 9</a:t>
             </a:r>
           </a:p>
         </p:txBody>

</xml_diff>